<commit_message>
Add batch optimization system for 12 clustering methods
- optimization/preprocess.py: data preprocessing + SHAP analysis → preprocessed.pkl
- optimization/common/: cost function (cluster-median normalized 4σ range %), utilities
- optimization/optimize/01-13: Optuna-based hyperparameter optimization per method
  - Methods: DT, KMeans, AE+KMeans, GMM, BisectingKMeans, Agglomerative, Spectral,
    IsolationForest+KMeans, VAE+KMeans, DT+KMeans 2-stage, XGBLeaf+KMeans, 4σ-Direct
  - Removed HDBSCAN (wrong inductive bias for continuous-density layout data)
- optimization/cost_function.json: fixed params (alpha, beta, min_count, percentiles)
- Cost function: α×weighted_mean(4σ%) + β×max(4σ%), cluster-median normalized
  (measures residual variation after OPC recipe CD correction)

Co-Authored-By: Claude Sonnet 4.6 <noreply@anthropic.com>
</commit_message>
<xml_diff>
--- a/output/clustering_methods_exec.pptx
+++ b/output/clustering_methods_exec.pptx
@@ -3097,9 +3097,121 @@
         <p:nvPr/>
       </p:nvGrpSpPr>
       <p:grpSpPr/>
+      <p:sp>
+        <p:nvSpPr>
+          <p:cNvPr id="2" name="Rectangle 1"/>
+          <p:cNvSpPr/>
+          <p:nvPr/>
+        </p:nvSpPr>
+        <p:spPr>
+          <a:xfrm>
+            <a:off x="0" y="0"/>
+            <a:ext cx="12188952" cy="685800"/>
+          </a:xfrm>
+          <a:prstGeom prst="rect">
+            <a:avLst/>
+          </a:prstGeom>
+          <a:solidFill>
+            <a:srgbClr val="1565C0"/>
+          </a:solidFill>
+          <a:ln>
+            <a:solidFill>
+              <a:srgbClr val="1565C0"/>
+            </a:solidFill>
+          </a:ln>
+        </p:spPr>
+        <p:style>
+          <a:lnRef idx="1">
+            <a:schemeClr val="accent1"/>
+          </a:lnRef>
+          <a:fillRef idx="3">
+            <a:schemeClr val="accent1"/>
+          </a:fillRef>
+          <a:effectRef idx="2">
+            <a:schemeClr val="accent1"/>
+          </a:effectRef>
+          <a:fontRef idx="minor">
+            <a:schemeClr val="lt1"/>
+          </a:fontRef>
+        </p:style>
+        <p:txBody>
+          <a:bodyPr rtlCol="0" anchor="ctr"/>
+          <a:lstStyle/>
+          <a:p>
+            <a:pPr algn="ctr"/>
+          </a:p>
+        </p:txBody>
+      </p:sp>
+      <p:sp>
+        <p:nvSpPr>
+          <p:cNvPr id="3" name="TextBox 2"/>
+          <p:cNvSpPr txBox="1"/>
+          <p:nvPr/>
+        </p:nvSpPr>
+        <p:spPr>
+          <a:xfrm>
+            <a:off x="182880" y="0"/>
+            <a:ext cx="8229600" cy="685800"/>
+          </a:xfrm>
+          <a:prstGeom prst="rect">
+            <a:avLst/>
+          </a:prstGeom>
+          <a:noFill/>
+        </p:spPr>
+        <p:txBody>
+          <a:bodyPr wrap="square">
+            <a:spAutoFit/>
+          </a:bodyPr>
+          <a:lstStyle/>
+          <a:p>
+            <a:r>
+              <a:rPr sz="2400" b="1">
+                <a:solidFill>
+                  <a:srgbClr val="FFFFFF"/>
+                </a:solidFill>
+              </a:rPr>
+              <a:t>01  |  Decision Tree Clustering</a:t>
+            </a:r>
+          </a:p>
+        </p:txBody>
+      </p:sp>
+      <p:sp>
+        <p:nvSpPr>
+          <p:cNvPr id="4" name="TextBox 3"/>
+          <p:cNvSpPr txBox="1"/>
+          <p:nvPr/>
+        </p:nvSpPr>
+        <p:spPr>
+          <a:xfrm>
+            <a:off x="8686800" y="0"/>
+            <a:ext cx="3291840" cy="685800"/>
+          </a:xfrm>
+          <a:prstGeom prst="rect">
+            <a:avLst/>
+          </a:prstGeom>
+          <a:noFill/>
+        </p:spPr>
+        <p:txBody>
+          <a:bodyPr wrap="square">
+            <a:spAutoFit/>
+          </a:bodyPr>
+          <a:lstStyle/>
+          <a:p>
+            <a:pPr algn="r"/>
+            <a:r>
+              <a:rPr sz="1100">
+                <a:solidFill>
+                  <a:srgbClr val="C8DCFF"/>
+                </a:solidFill>
+              </a:rPr>
+              <a:t>In-House Layout Feature Clustering</a:t>
+            </a:r>
+          </a:p>
+        </p:txBody>
+      </p:sp>
       <p:pic>
         <p:nvPicPr>
-          <p:cNvPr id="2" name="Picture 1" descr="exec_slide_01_decision_tree.png"/>
+          <p:cNvPr id="5" name="Picture 4" descr="10_decision_tree_iris.png"/>
           <p:cNvPicPr>
             <a:picLocks noChangeAspect="1"/>
           </p:cNvPicPr>
@@ -3113,14 +3225,278 @@
         </p:blipFill>
         <p:spPr>
           <a:xfrm>
-            <a:off x="0" y="0"/>
-            <a:ext cx="12188952" cy="6858000"/>
+            <a:off x="182880" y="777240"/>
+            <a:ext cx="7863840" cy="5852160"/>
           </a:xfrm>
           <a:prstGeom prst="rect">
             <a:avLst/>
           </a:prstGeom>
         </p:spPr>
       </p:pic>
+      <p:sp>
+        <p:nvSpPr>
+          <p:cNvPr id="6" name="Rectangle 5"/>
+          <p:cNvSpPr/>
+          <p:nvPr/>
+        </p:nvSpPr>
+        <p:spPr>
+          <a:xfrm>
+            <a:off x="8275320" y="777240"/>
+            <a:ext cx="3730752" cy="5852160"/>
+          </a:xfrm>
+          <a:prstGeom prst="rect">
+            <a:avLst/>
+          </a:prstGeom>
+          <a:solidFill>
+            <a:srgbClr val="F0F4FF"/>
+          </a:solidFill>
+          <a:ln w="12700">
+            <a:solidFill>
+              <a:srgbClr val="C8D7F5"/>
+            </a:solidFill>
+          </a:ln>
+        </p:spPr>
+        <p:style>
+          <a:lnRef idx="1">
+            <a:schemeClr val="accent1"/>
+          </a:lnRef>
+          <a:fillRef idx="3">
+            <a:schemeClr val="accent1"/>
+          </a:fillRef>
+          <a:effectRef idx="2">
+            <a:schemeClr val="accent1"/>
+          </a:effectRef>
+          <a:fontRef idx="minor">
+            <a:schemeClr val="lt1"/>
+          </a:fontRef>
+        </p:style>
+        <p:txBody>
+          <a:bodyPr rtlCol="0" anchor="ctr"/>
+          <a:lstStyle/>
+          <a:p>
+            <a:pPr algn="ctr"/>
+          </a:p>
+        </p:txBody>
+      </p:sp>
+      <p:sp>
+        <p:nvSpPr>
+          <p:cNvPr id="7" name="TextBox 6"/>
+          <p:cNvSpPr txBox="1"/>
+          <p:nvPr/>
+        </p:nvSpPr>
+        <p:spPr>
+          <a:xfrm>
+            <a:off x="8366760" y="822960"/>
+            <a:ext cx="3566160" cy="5669280"/>
+          </a:xfrm>
+          <a:prstGeom prst="rect">
+            <a:avLst/>
+          </a:prstGeom>
+          <a:noFill/>
+        </p:spPr>
+        <p:txBody>
+          <a:bodyPr wrap="square">
+            <a:spAutoFit/>
+          </a:bodyPr>
+          <a:lstStyle/>
+          <a:p>
+            <a:r>
+              <a:rPr sz="1100">
+                <a:solidFill>
+                  <a:srgbClr val="1E1E3C"/>
+                </a:solidFill>
+              </a:rPr>
+              <a:t>Algorithm Summary</a:t>
+            </a:r>
+          </a:p>
+          <a:p/>
+          <a:p>
+            <a:r>
+              <a:rPr sz="1100">
+                <a:solidFill>
+                  <a:srgbClr val="1E1E3C"/>
+                </a:solidFill>
+              </a:rPr>
+              <a:t>Category: Rule-Based</a:t>
+            </a:r>
+          </a:p>
+          <a:p/>
+          <a:p>
+            <a:r>
+              <a:rPr sz="1100">
+                <a:solidFill>
+                  <a:srgbClr val="1E1E3C"/>
+                </a:solidFill>
+              </a:rPr>
+              <a:t>Core Idea</a:t>
+            </a:r>
+          </a:p>
+          <a:p>
+            <a:r>
+              <a:rPr sz="1100">
+                <a:solidFill>
+                  <a:srgbClr val="1E1E3C"/>
+                </a:solidFill>
+              </a:rPr>
+              <a:t>트리 각 말단 노드(leaf)를 하나의 클러스터로 정의. 깊이(depth)가 클러스터 수를 결정.</a:t>
+            </a:r>
+          </a:p>
+          <a:p/>
+          <a:p>
+            <a:r>
+              <a:rPr sz="1100">
+                <a:solidFill>
+                  <a:srgbClr val="1E1E3C"/>
+                </a:solidFill>
+              </a:rPr>
+              <a:t>Key Steps</a:t>
+            </a:r>
+          </a:p>
+          <a:p>
+            <a:r>
+              <a:rPr sz="1100">
+                <a:solidFill>
+                  <a:srgbClr val="1E1E3C"/>
+                </a:solidFill>
+              </a:rPr>
+              <a:t>① Feature 기준 재귀적 이진 분할</a:t>
+            </a:r>
+          </a:p>
+          <a:p>
+            <a:r>
+              <a:rPr sz="1100">
+                <a:solidFill>
+                  <a:srgbClr val="1E1E3C"/>
+                </a:solidFill>
+              </a:rPr>
+              <a:t>② 각 leaf node = cluster label</a:t>
+            </a:r>
+          </a:p>
+          <a:p>
+            <a:r>
+              <a:rPr sz="1100">
+                <a:solidFill>
+                  <a:srgbClr val="1E1E3C"/>
+                </a:solidFill>
+              </a:rPr>
+              <a:t>③ depth 제어로 granularity 조정</a:t>
+            </a:r>
+          </a:p>
+          <a:p/>
+          <a:p>
+            <a:r>
+              <a:rPr sz="1100">
+                <a:solidFill>
+                  <a:srgbClr val="1E1E3C"/>
+                </a:solidFill>
+              </a:rPr>
+              <a:t>Split Criterion</a:t>
+            </a:r>
+          </a:p>
+          <a:p>
+            <a:r>
+              <a:rPr sz="1100">
+                <a:solidFill>
+                  <a:srgbClr val="1E1E3C"/>
+                </a:solidFill>
+              </a:rPr>
+              <a:t>• Gini impurity / Variance reduction</a:t>
+            </a:r>
+          </a:p>
+          <a:p>
+            <a:r>
+              <a:rPr sz="1100">
+                <a:solidFill>
+                  <a:srgbClr val="1E1E3C"/>
+                </a:solidFill>
+              </a:rPr>
+              <a:t>• 분할 기준: 축-정렬(axis-aligned)</a:t>
+            </a:r>
+          </a:p>
+          <a:p/>
+          <a:p>
+            <a:r>
+              <a:rPr sz="1100">
+                <a:solidFill>
+                  <a:srgbClr val="1E1E3C"/>
+                </a:solidFill>
+              </a:rPr>
+              <a:t>Properties</a:t>
+            </a:r>
+          </a:p>
+          <a:p>
+            <a:r>
+              <a:rPr sz="1100">
+                <a:solidFill>
+                  <a:srgbClr val="1E1E3C"/>
+                </a:solidFill>
+              </a:rPr>
+              <a:t>✓ 해석 가능한 분류 규칙 제공</a:t>
+            </a:r>
+          </a:p>
+          <a:p>
+            <a:r>
+              <a:rPr sz="1100">
+                <a:solidFill>
+                  <a:srgbClr val="1E1E3C"/>
+                </a:solidFill>
+              </a:rPr>
+              <a:t>✓ O(depth) 빠른 추론 속도</a:t>
+            </a:r>
+          </a:p>
+          <a:p>
+            <a:r>
+              <a:rPr sz="1100">
+                <a:solidFill>
+                  <a:srgbClr val="1E1E3C"/>
+                </a:solidFill>
+              </a:rPr>
+              <a:t>✓ Mixed feature type 처리</a:t>
+            </a:r>
+          </a:p>
+          <a:p>
+            <a:r>
+              <a:rPr sz="1100">
+                <a:solidFill>
+                  <a:srgbClr val="1E1E3C"/>
+                </a:solidFill>
+              </a:rPr>
+              <a:t>△ 깊은 트리 = 과분할 위험</a:t>
+            </a:r>
+          </a:p>
+          <a:p/>
+          <a:p>
+            <a:r>
+              <a:rPr sz="1100">
+                <a:solidFill>
+                  <a:srgbClr val="1E1E3C"/>
+                </a:solidFill>
+              </a:rPr>
+              <a:t>Reference</a:t>
+            </a:r>
+          </a:p>
+          <a:p>
+            <a:r>
+              <a:rPr sz="1100">
+                <a:solidFill>
+                  <a:srgbClr val="1E1E3C"/>
+                </a:solidFill>
+              </a:rPr>
+              <a:t>Breiman et al. (1984)</a:t>
+            </a:r>
+          </a:p>
+          <a:p>
+            <a:r>
+              <a:rPr sz="1100">
+                <a:solidFill>
+                  <a:srgbClr val="1E1E3C"/>
+                </a:solidFill>
+              </a:rPr>
+              <a:t>CART: Classification &amp; Regression Trees</a:t>
+            </a:r>
+          </a:p>
+        </p:txBody>
+      </p:sp>
     </p:spTree>
   </p:cSld>
   <p:clrMapOvr>
@@ -3139,9 +3515,87 @@
         <p:nvPr/>
       </p:nvGrpSpPr>
       <p:grpSpPr/>
+      <p:sp>
+        <p:nvSpPr>
+          <p:cNvPr id="2" name="Rectangle 1"/>
+          <p:cNvSpPr/>
+          <p:nvPr/>
+        </p:nvSpPr>
+        <p:spPr>
+          <a:xfrm>
+            <a:off x="0" y="0"/>
+            <a:ext cx="12188952" cy="685800"/>
+          </a:xfrm>
+          <a:prstGeom prst="rect">
+            <a:avLst/>
+          </a:prstGeom>
+          <a:solidFill>
+            <a:srgbClr val="0277BD"/>
+          </a:solidFill>
+          <a:ln>
+            <a:solidFill>
+              <a:srgbClr val="0277BD"/>
+            </a:solidFill>
+          </a:ln>
+        </p:spPr>
+        <p:style>
+          <a:lnRef idx="1">
+            <a:schemeClr val="accent1"/>
+          </a:lnRef>
+          <a:fillRef idx="3">
+            <a:schemeClr val="accent1"/>
+          </a:fillRef>
+          <a:effectRef idx="2">
+            <a:schemeClr val="accent1"/>
+          </a:effectRef>
+          <a:fontRef idx="minor">
+            <a:schemeClr val="lt1"/>
+          </a:fontRef>
+        </p:style>
+        <p:txBody>
+          <a:bodyPr rtlCol="0" anchor="ctr"/>
+          <a:lstStyle/>
+          <a:p>
+            <a:pPr algn="ctr"/>
+          </a:p>
+        </p:txBody>
+      </p:sp>
+      <p:sp>
+        <p:nvSpPr>
+          <p:cNvPr id="3" name="TextBox 2"/>
+          <p:cNvSpPr txBox="1"/>
+          <p:nvPr/>
+        </p:nvSpPr>
+        <p:spPr>
+          <a:xfrm>
+            <a:off x="182880" y="0"/>
+            <a:ext cx="8229600" cy="685800"/>
+          </a:xfrm>
+          <a:prstGeom prst="rect">
+            <a:avLst/>
+          </a:prstGeom>
+          <a:noFill/>
+        </p:spPr>
+        <p:txBody>
+          <a:bodyPr wrap="square">
+            <a:spAutoFit/>
+          </a:bodyPr>
+          <a:lstStyle/>
+          <a:p>
+            <a:r>
+              <a:rPr sz="2100" b="1">
+                <a:solidFill>
+                  <a:srgbClr val="FFFFFF"/>
+                </a:solidFill>
+              </a:rPr>
+              <a:t>10  |  Variational Autoencoder + K-Means  (VAE)</a:t>
+            </a:r>
+          </a:p>
+        </p:txBody>
+      </p:sp>
       <p:pic>
         <p:nvPicPr>
-          <p:cNvPr id="2" name="Picture 1" descr="exec_slide_10_vae_kmeans.png"/>
+          <p:cNvPr id="4" name="Picture 3" descr="09_vae.png"/>
           <p:cNvPicPr>
             <a:picLocks noChangeAspect="1"/>
           </p:cNvPicPr>
@@ -3155,14 +3609,380 @@
         </p:blipFill>
         <p:spPr>
           <a:xfrm>
-            <a:off x="0" y="0"/>
-            <a:ext cx="12188952" cy="6858000"/>
+            <a:off x="182880" y="777240"/>
+            <a:ext cx="7863840" cy="5852160"/>
           </a:xfrm>
           <a:prstGeom prst="rect">
             <a:avLst/>
           </a:prstGeom>
         </p:spPr>
       </p:pic>
+      <p:sp>
+        <p:nvSpPr>
+          <p:cNvPr id="5" name="Rectangle 4"/>
+          <p:cNvSpPr/>
+          <p:nvPr/>
+        </p:nvSpPr>
+        <p:spPr>
+          <a:xfrm>
+            <a:off x="8275320" y="777240"/>
+            <a:ext cx="3730752" cy="5852160"/>
+          </a:xfrm>
+          <a:prstGeom prst="rect">
+            <a:avLst/>
+          </a:prstGeom>
+          <a:solidFill>
+            <a:srgbClr val="E3F2FD"/>
+          </a:solidFill>
+          <a:ln w="12700">
+            <a:solidFill>
+              <a:srgbClr val="90CAF9"/>
+            </a:solidFill>
+          </a:ln>
+        </p:spPr>
+        <p:style>
+          <a:lnRef idx="1">
+            <a:schemeClr val="accent1"/>
+          </a:lnRef>
+          <a:fillRef idx="3">
+            <a:schemeClr val="accent1"/>
+          </a:fillRef>
+          <a:effectRef idx="2">
+            <a:schemeClr val="accent1"/>
+          </a:effectRef>
+          <a:fontRef idx="minor">
+            <a:schemeClr val="lt1"/>
+          </a:fontRef>
+        </p:style>
+        <p:txBody>
+          <a:bodyPr rtlCol="0" anchor="ctr"/>
+          <a:lstStyle/>
+          <a:p>
+            <a:pPr algn="ctr"/>
+          </a:p>
+        </p:txBody>
+      </p:sp>
+      <p:sp>
+        <p:nvSpPr>
+          <p:cNvPr id="6" name="TextBox 5"/>
+          <p:cNvSpPr txBox="1"/>
+          <p:nvPr/>
+        </p:nvSpPr>
+        <p:spPr>
+          <a:xfrm>
+            <a:off x="8366760" y="822960"/>
+            <a:ext cx="3566160" cy="5669280"/>
+          </a:xfrm>
+          <a:prstGeom prst="rect">
+            <a:avLst/>
+          </a:prstGeom>
+          <a:noFill/>
+        </p:spPr>
+        <p:txBody>
+          <a:bodyPr wrap="square">
+            <a:spAutoFit/>
+          </a:bodyPr>
+          <a:lstStyle/>
+          <a:p>
+            <a:r>
+              <a:rPr sz="1100">
+                <a:solidFill>
+                  <a:srgbClr val="051E3C"/>
+                </a:solidFill>
+              </a:rPr>
+              <a:t>Algorithm Summary</a:t>
+            </a:r>
+          </a:p>
+          <a:p/>
+          <a:p>
+            <a:r>
+              <a:rPr sz="1100">
+                <a:solidFill>
+                  <a:srgbClr val="051E3C"/>
+                </a:solidFill>
+              </a:rPr>
+              <a:t>Category: Deep Generative</a:t>
+            </a:r>
+          </a:p>
+          <a:p/>
+          <a:p>
+            <a:r>
+              <a:rPr sz="1100">
+                <a:solidFill>
+                  <a:srgbClr val="051E3C"/>
+                </a:solidFill>
+              </a:rPr>
+              <a:t>Core Idea</a:t>
+            </a:r>
+          </a:p>
+          <a:p>
+            <a:r>
+              <a:rPr sz="1100">
+                <a:solidFill>
+                  <a:srgbClr val="051E3C"/>
+                </a:solidFill>
+              </a:rPr>
+              <a:t>확률적 잠재 공간 학습: z ~ N(μ(x), σ²(x)). Reparameterization trick으로 역전파 가능.</a:t>
+            </a:r>
+          </a:p>
+          <a:p/>
+          <a:p>
+            <a:r>
+              <a:rPr sz="1100">
+                <a:solidFill>
+                  <a:srgbClr val="051E3C"/>
+                </a:solidFill>
+              </a:rPr>
+              <a:t>Architecture</a:t>
+            </a:r>
+          </a:p>
+          <a:p>
+            <a:r>
+              <a:rPr sz="1100">
+                <a:solidFill>
+                  <a:srgbClr val="051E3C"/>
+                </a:solidFill>
+              </a:rPr>
+              <a:t>Input(126) → Encoder</a:t>
+            </a:r>
+          </a:p>
+          <a:p>
+            <a:r>
+              <a:rPr sz="1100">
+                <a:solidFill>
+                  <a:srgbClr val="051E3C"/>
+                </a:solidFill>
+              </a:rPr>
+              <a:t>→ μ(x), log σ²(x)</a:t>
+            </a:r>
+          </a:p>
+          <a:p>
+            <a:r>
+              <a:rPr sz="1100">
+                <a:solidFill>
+                  <a:srgbClr val="051E3C"/>
+                </a:solidFill>
+              </a:rPr>
+              <a:t>→ z = μ + ε·σ  (ε~N(0,I))  ← K-Means</a:t>
+            </a:r>
+          </a:p>
+          <a:p>
+            <a:r>
+              <a:rPr sz="1100">
+                <a:solidFill>
+                  <a:srgbClr val="051E3C"/>
+                </a:solidFill>
+              </a:rPr>
+              <a:t>→ Decoder → x̂(126)</a:t>
+            </a:r>
+          </a:p>
+          <a:p/>
+          <a:p>
+            <a:r>
+              <a:rPr sz="1100">
+                <a:solidFill>
+                  <a:srgbClr val="051E3C"/>
+                </a:solidFill>
+              </a:rPr>
+              <a:t>ELBO Loss</a:t>
+            </a:r>
+          </a:p>
+          <a:p>
+            <a:r>
+              <a:rPr sz="1100">
+                <a:solidFill>
+                  <a:srgbClr val="051E3C"/>
+                </a:solidFill>
+              </a:rPr>
+              <a:t>L = E[log p(x|z)] − β·KL(q‖p)</a:t>
+            </a:r>
+          </a:p>
+          <a:p>
+            <a:r>
+              <a:rPr sz="1100">
+                <a:solidFill>
+                  <a:srgbClr val="051E3C"/>
+                </a:solidFill>
+              </a:rPr>
+              <a:t>· Reconstruction: MSE</a:t>
+            </a:r>
+          </a:p>
+          <a:p>
+            <a:r>
+              <a:rPr sz="1100">
+                <a:solidFill>
+                  <a:srgbClr val="051E3C"/>
+                </a:solidFill>
+              </a:rPr>
+              <a:t>· KL: z를 N(0,I)로 정규화</a:t>
+            </a:r>
+          </a:p>
+          <a:p>
+            <a:r>
+              <a:rPr sz="1100">
+                <a:solidFill>
+                  <a:srgbClr val="051E3C"/>
+                </a:solidFill>
+              </a:rPr>
+              <a:t>· β &gt; 1: 더 강한 disentanglement</a:t>
+            </a:r>
+          </a:p>
+          <a:p/>
+          <a:p>
+            <a:r>
+              <a:rPr sz="1100">
+                <a:solidFill>
+                  <a:srgbClr val="051E3C"/>
+                </a:solidFill>
+              </a:rPr>
+              <a:t>vs AE (Autoencoder)</a:t>
+            </a:r>
+          </a:p>
+          <a:p>
+            <a:r>
+              <a:rPr sz="1100">
+                <a:solidFill>
+                  <a:srgbClr val="051E3C"/>
+                </a:solidFill>
+              </a:rPr>
+              <a:t>• AE: z 결정론적, 공간 불규칙</a:t>
+            </a:r>
+          </a:p>
+          <a:p>
+            <a:r>
+              <a:rPr sz="1100">
+                <a:solidFill>
+                  <a:srgbClr val="051E3C"/>
+                </a:solidFill>
+              </a:rPr>
+              <a:t>• VAE: z 확률적, 공간 매끄럽고</a:t>
+            </a:r>
+          </a:p>
+          <a:p>
+            <a:r>
+              <a:rPr sz="1100">
+                <a:solidFill>
+                  <a:srgbClr val="051E3C"/>
+                </a:solidFill>
+              </a:rPr>
+              <a:t>  클러스터 경계 더 명확</a:t>
+            </a:r>
+          </a:p>
+          <a:p/>
+          <a:p>
+            <a:r>
+              <a:rPr sz="1100">
+                <a:solidFill>
+                  <a:srgbClr val="051E3C"/>
+                </a:solidFill>
+              </a:rPr>
+              <a:t>K-Means on z</a:t>
+            </a:r>
+          </a:p>
+          <a:p>
+            <a:r>
+              <a:rPr sz="1100">
+                <a:solidFill>
+                  <a:srgbClr val="051E3C"/>
+                </a:solidFill>
+              </a:rPr>
+              <a:t>정규화된 latent space에서</a:t>
+            </a:r>
+          </a:p>
+          <a:p>
+            <a:r>
+              <a:rPr sz="1100">
+                <a:solidFill>
+                  <a:srgbClr val="051E3C"/>
+                </a:solidFill>
+              </a:rPr>
+              <a:t>클러스터 구조가 더 선명</a:t>
+            </a:r>
+          </a:p>
+          <a:p/>
+          <a:p>
+            <a:r>
+              <a:rPr sz="1100">
+                <a:solidFill>
+                  <a:srgbClr val="051E3C"/>
+                </a:solidFill>
+              </a:rPr>
+              <a:t>Properties</a:t>
+            </a:r>
+          </a:p>
+          <a:p>
+            <a:r>
+              <a:rPr sz="1100">
+                <a:solidFill>
+                  <a:srgbClr val="051E3C"/>
+                </a:solidFill>
+              </a:rPr>
+              <a:t>✓ 구조화된 latent manifold</a:t>
+            </a:r>
+          </a:p>
+          <a:p>
+            <a:r>
+              <a:rPr sz="1100">
+                <a:solidFill>
+                  <a:srgbClr val="051E3C"/>
+                </a:solidFill>
+              </a:rPr>
+              <a:t>✓ 새로운 샘플 생성 가능 (generative)</a:t>
+            </a:r>
+          </a:p>
+          <a:p>
+            <a:r>
+              <a:rPr sz="1100">
+                <a:solidFill>
+                  <a:srgbClr val="051E3C"/>
+                </a:solidFill>
+              </a:rPr>
+              <a:t>✓ KL term으로 z 공간 규칙화</a:t>
+            </a:r>
+          </a:p>
+          <a:p>
+            <a:r>
+              <a:rPr sz="1100">
+                <a:solidFill>
+                  <a:srgbClr val="051E3C"/>
+                </a:solidFill>
+              </a:rPr>
+              <a:t>✓ β로 clustering quality 조절</a:t>
+            </a:r>
+          </a:p>
+          <a:p/>
+          <a:p>
+            <a:r>
+              <a:rPr sz="1100">
+                <a:solidFill>
+                  <a:srgbClr val="051E3C"/>
+                </a:solidFill>
+              </a:rPr>
+              <a:t>Reference</a:t>
+            </a:r>
+          </a:p>
+          <a:p>
+            <a:r>
+              <a:rPr sz="1100">
+                <a:solidFill>
+                  <a:srgbClr val="051E3C"/>
+                </a:solidFill>
+              </a:rPr>
+              <a:t>Kingma &amp; Welling (2014), ICLR</a:t>
+            </a:r>
+          </a:p>
+          <a:p>
+            <a:r>
+              <a:rPr sz="1100">
+                <a:solidFill>
+                  <a:srgbClr val="051E3C"/>
+                </a:solidFill>
+              </a:rPr>
+              <a:t>Jiang et al., VaDE, IJCAI 2017</a:t>
+            </a:r>
+          </a:p>
+        </p:txBody>
+      </p:sp>
     </p:spTree>
   </p:cSld>
   <p:clrMapOvr>
@@ -3181,9 +4001,87 @@
         <p:nvPr/>
       </p:nvGrpSpPr>
       <p:grpSpPr/>
+      <p:sp>
+        <p:nvSpPr>
+          <p:cNvPr id="2" name="Rectangle 1"/>
+          <p:cNvSpPr/>
+          <p:nvPr/>
+        </p:nvSpPr>
+        <p:spPr>
+          <a:xfrm>
+            <a:off x="0" y="0"/>
+            <a:ext cx="12188952" cy="685800"/>
+          </a:xfrm>
+          <a:prstGeom prst="rect">
+            <a:avLst/>
+          </a:prstGeom>
+          <a:solidFill>
+            <a:srgbClr val="2E7D32"/>
+          </a:solidFill>
+          <a:ln>
+            <a:solidFill>
+              <a:srgbClr val="2E7D32"/>
+            </a:solidFill>
+          </a:ln>
+        </p:spPr>
+        <p:style>
+          <a:lnRef idx="1">
+            <a:schemeClr val="accent1"/>
+          </a:lnRef>
+          <a:fillRef idx="3">
+            <a:schemeClr val="accent1"/>
+          </a:fillRef>
+          <a:effectRef idx="2">
+            <a:schemeClr val="accent1"/>
+          </a:effectRef>
+          <a:fontRef idx="minor">
+            <a:schemeClr val="lt1"/>
+          </a:fontRef>
+        </p:style>
+        <p:txBody>
+          <a:bodyPr rtlCol="0" anchor="ctr"/>
+          <a:lstStyle/>
+          <a:p>
+            <a:pPr algn="ctr"/>
+          </a:p>
+        </p:txBody>
+      </p:sp>
+      <p:sp>
+        <p:nvSpPr>
+          <p:cNvPr id="3" name="TextBox 2"/>
+          <p:cNvSpPr txBox="1"/>
+          <p:nvPr/>
+        </p:nvSpPr>
+        <p:spPr>
+          <a:xfrm>
+            <a:off x="182880" y="0"/>
+            <a:ext cx="8229600" cy="685800"/>
+          </a:xfrm>
+          <a:prstGeom prst="rect">
+            <a:avLst/>
+          </a:prstGeom>
+          <a:noFill/>
+        </p:spPr>
+        <p:txBody>
+          <a:bodyPr wrap="square">
+            <a:spAutoFit/>
+          </a:bodyPr>
+          <a:lstStyle/>
+          <a:p>
+            <a:r>
+              <a:rPr sz="2400" b="1">
+                <a:solidFill>
+                  <a:srgbClr val="FFFFFF"/>
+                </a:solidFill>
+              </a:rPr>
+              <a:t>02  |  K-Means Clustering  (MiniBatch)</a:t>
+            </a:r>
+          </a:p>
+        </p:txBody>
+      </p:sp>
       <p:pic>
         <p:nvPicPr>
-          <p:cNvPr id="2" name="Picture 1" descr="exec_slide_02_kmeans_minibatch.png"/>
+          <p:cNvPr id="4" name="Picture 3" descr="kmeans_minibatch.png"/>
           <p:cNvPicPr>
             <a:picLocks noChangeAspect="1"/>
           </p:cNvPicPr>
@@ -3197,14 +4095,299 @@
         </p:blipFill>
         <p:spPr>
           <a:xfrm>
-            <a:off x="0" y="0"/>
-            <a:ext cx="12188952" cy="6858000"/>
+            <a:off x="182880" y="777240"/>
+            <a:ext cx="7863840" cy="5852160"/>
           </a:xfrm>
           <a:prstGeom prst="rect">
             <a:avLst/>
           </a:prstGeom>
         </p:spPr>
       </p:pic>
+      <p:sp>
+        <p:nvSpPr>
+          <p:cNvPr id="5" name="Rectangle 4"/>
+          <p:cNvSpPr/>
+          <p:nvPr/>
+        </p:nvSpPr>
+        <p:spPr>
+          <a:xfrm>
+            <a:off x="8275320" y="777240"/>
+            <a:ext cx="3730752" cy="5852160"/>
+          </a:xfrm>
+          <a:prstGeom prst="rect">
+            <a:avLst/>
+          </a:prstGeom>
+          <a:solidFill>
+            <a:srgbClr val="F1F8E9"/>
+          </a:solidFill>
+          <a:ln w="12700">
+            <a:solidFill>
+              <a:srgbClr val="C8E6C9"/>
+            </a:solidFill>
+          </a:ln>
+        </p:spPr>
+        <p:style>
+          <a:lnRef idx="1">
+            <a:schemeClr val="accent1"/>
+          </a:lnRef>
+          <a:fillRef idx="3">
+            <a:schemeClr val="accent1"/>
+          </a:fillRef>
+          <a:effectRef idx="2">
+            <a:schemeClr val="accent1"/>
+          </a:effectRef>
+          <a:fontRef idx="minor">
+            <a:schemeClr val="lt1"/>
+          </a:fontRef>
+        </p:style>
+        <p:txBody>
+          <a:bodyPr rtlCol="0" anchor="ctr"/>
+          <a:lstStyle/>
+          <a:p>
+            <a:pPr algn="ctr"/>
+          </a:p>
+        </p:txBody>
+      </p:sp>
+      <p:sp>
+        <p:nvSpPr>
+          <p:cNvPr id="6" name="TextBox 5"/>
+          <p:cNvSpPr txBox="1"/>
+          <p:nvPr/>
+        </p:nvSpPr>
+        <p:spPr>
+          <a:xfrm>
+            <a:off x="8366760" y="822960"/>
+            <a:ext cx="3566160" cy="5669280"/>
+          </a:xfrm>
+          <a:prstGeom prst="rect">
+            <a:avLst/>
+          </a:prstGeom>
+          <a:noFill/>
+        </p:spPr>
+        <p:txBody>
+          <a:bodyPr wrap="square">
+            <a:spAutoFit/>
+          </a:bodyPr>
+          <a:lstStyle/>
+          <a:p>
+            <a:r>
+              <a:rPr sz="1100">
+                <a:solidFill>
+                  <a:srgbClr val="143214"/>
+                </a:solidFill>
+              </a:rPr>
+              <a:t>Algorithm Summary</a:t>
+            </a:r>
+          </a:p>
+          <a:p/>
+          <a:p>
+            <a:r>
+              <a:rPr sz="1100">
+                <a:solidFill>
+                  <a:srgbClr val="143214"/>
+                </a:solidFill>
+              </a:rPr>
+              <a:t>Category: Partition-based</a:t>
+            </a:r>
+          </a:p>
+          <a:p/>
+          <a:p>
+            <a:r>
+              <a:rPr sz="1100">
+                <a:solidFill>
+                  <a:srgbClr val="143214"/>
+                </a:solidFill>
+              </a:rPr>
+              <a:t>Core Idea</a:t>
+            </a:r>
+          </a:p>
+          <a:p>
+            <a:r>
+              <a:rPr sz="1100">
+                <a:solidFill>
+                  <a:srgbClr val="143214"/>
+                </a:solidFill>
+              </a:rPr>
+              <a:t>n개 데이터를 k개 구형 클러스터로 분할. Inertia(within-cluster SSE) 최소화.</a:t>
+            </a:r>
+          </a:p>
+          <a:p/>
+          <a:p>
+            <a:r>
+              <a:rPr sz="1100">
+                <a:solidFill>
+                  <a:srgbClr val="143214"/>
+                </a:solidFill>
+              </a:rPr>
+              <a:t>Key Steps</a:t>
+            </a:r>
+          </a:p>
+          <a:p>
+            <a:r>
+              <a:rPr sz="1100">
+                <a:solidFill>
+                  <a:srgbClr val="143214"/>
+                </a:solidFill>
+              </a:rPr>
+              <a:t>① k-means++ 초기화 (centroids 분산)</a:t>
+            </a:r>
+          </a:p>
+          <a:p>
+            <a:r>
+              <a:rPr sz="1100">
+                <a:solidFill>
+                  <a:srgbClr val="143214"/>
+                </a:solidFill>
+              </a:rPr>
+              <a:t>② Mini-batch B ⊂ X 샘플링</a:t>
+            </a:r>
+          </a:p>
+          <a:p>
+            <a:r>
+              <a:rPr sz="1100">
+                <a:solidFill>
+                  <a:srgbClr val="143214"/>
+                </a:solidFill>
+              </a:rPr>
+              <a:t>③ 최근접 centroid 할당 (유클리드)</a:t>
+            </a:r>
+          </a:p>
+          <a:p>
+            <a:r>
+              <a:rPr sz="1100">
+                <a:solidFill>
+                  <a:srgbClr val="143214"/>
+                </a:solidFill>
+              </a:rPr>
+              <a:t>④ 지수이동평균으로 centroid 업데이트</a:t>
+            </a:r>
+          </a:p>
+          <a:p>
+            <a:r>
+              <a:rPr sz="1100">
+                <a:solidFill>
+                  <a:srgbClr val="143214"/>
+                </a:solidFill>
+              </a:rPr>
+              <a:t>⑤ 수렴까지 반복</a:t>
+            </a:r>
+          </a:p>
+          <a:p/>
+          <a:p>
+            <a:r>
+              <a:rPr sz="1100">
+                <a:solidFill>
+                  <a:srgbClr val="143214"/>
+                </a:solidFill>
+              </a:rPr>
+              <a:t>Objective Function</a:t>
+            </a:r>
+          </a:p>
+          <a:p>
+            <a:r>
+              <a:rPr sz="1100">
+                <a:solidFill>
+                  <a:srgbClr val="143214"/>
+                </a:solidFill>
+              </a:rPr>
+              <a:t>min Σ min‖xᵢ − μⱼ‖²</a:t>
+            </a:r>
+          </a:p>
+          <a:p/>
+          <a:p>
+            <a:r>
+              <a:rPr sz="1100">
+                <a:solidFill>
+                  <a:srgbClr val="143214"/>
+                </a:solidFill>
+              </a:rPr>
+              <a:t>Decision Boundary: Voronoi 다이어그램</a:t>
+            </a:r>
+          </a:p>
+          <a:p/>
+          <a:p>
+            <a:r>
+              <a:rPr sz="1100">
+                <a:solidFill>
+                  <a:srgbClr val="143214"/>
+                </a:solidFill>
+              </a:rPr>
+              <a:t>Properties</a:t>
+            </a:r>
+          </a:p>
+          <a:p>
+            <a:r>
+              <a:rPr sz="1100">
+                <a:solidFill>
+                  <a:srgbClr val="143214"/>
+                </a:solidFill>
+              </a:rPr>
+              <a:t>✓ 수백만 포인트 처리 가능</a:t>
+            </a:r>
+          </a:p>
+          <a:p>
+            <a:r>
+              <a:rPr sz="1100">
+                <a:solidFill>
+                  <a:srgbClr val="143214"/>
+                </a:solidFill>
+              </a:rPr>
+              <a:t>✓ 빠른 수렴, GPU 최적화</a:t>
+            </a:r>
+          </a:p>
+          <a:p>
+            <a:r>
+              <a:rPr sz="1100">
+                <a:solidFill>
+                  <a:srgbClr val="143214"/>
+                </a:solidFill>
+              </a:rPr>
+              <a:t>△ 구형 클러스터 가정</a:t>
+            </a:r>
+          </a:p>
+          <a:p>
+            <a:r>
+              <a:rPr sz="1100">
+                <a:solidFill>
+                  <a:srgbClr val="143214"/>
+                </a:solidFill>
+              </a:rPr>
+              <a:t>△ k 사전 지정 필요</a:t>
+            </a:r>
+          </a:p>
+          <a:p/>
+          <a:p>
+            <a:r>
+              <a:rPr sz="1100">
+                <a:solidFill>
+                  <a:srgbClr val="143214"/>
+                </a:solidFill>
+              </a:rPr>
+              <a:t>Reference</a:t>
+            </a:r>
+          </a:p>
+          <a:p>
+            <a:r>
+              <a:rPr sz="1100">
+                <a:solidFill>
+                  <a:srgbClr val="143214"/>
+                </a:solidFill>
+              </a:rPr>
+              <a:t>Sculley (2010). Web-Scale K-Means</a:t>
+            </a:r>
+          </a:p>
+          <a:p>
+            <a:r>
+              <a:rPr sz="1100">
+                <a:solidFill>
+                  <a:srgbClr val="143214"/>
+                </a:solidFill>
+              </a:rPr>
+              <a:t>Clustering. WWW 2010.</a:t>
+            </a:r>
+          </a:p>
+        </p:txBody>
+      </p:sp>
     </p:spTree>
   </p:cSld>
   <p:clrMapOvr>
@@ -3223,9 +4406,87 @@
         <p:nvPr/>
       </p:nvGrpSpPr>
       <p:grpSpPr/>
+      <p:sp>
+        <p:nvSpPr>
+          <p:cNvPr id="2" name="Rectangle 1"/>
+          <p:cNvSpPr/>
+          <p:nvPr/>
+        </p:nvSpPr>
+        <p:spPr>
+          <a:xfrm>
+            <a:off x="0" y="0"/>
+            <a:ext cx="12188952" cy="685800"/>
+          </a:xfrm>
+          <a:prstGeom prst="rect">
+            <a:avLst/>
+          </a:prstGeom>
+          <a:solidFill>
+            <a:srgbClr val="6A1B9A"/>
+          </a:solidFill>
+          <a:ln>
+            <a:solidFill>
+              <a:srgbClr val="6A1B9A"/>
+            </a:solidFill>
+          </a:ln>
+        </p:spPr>
+        <p:style>
+          <a:lnRef idx="1">
+            <a:schemeClr val="accent1"/>
+          </a:lnRef>
+          <a:fillRef idx="3">
+            <a:schemeClr val="accent1"/>
+          </a:fillRef>
+          <a:effectRef idx="2">
+            <a:schemeClr val="accent1"/>
+          </a:effectRef>
+          <a:fontRef idx="minor">
+            <a:schemeClr val="lt1"/>
+          </a:fontRef>
+        </p:style>
+        <p:txBody>
+          <a:bodyPr rtlCol="0" anchor="ctr"/>
+          <a:lstStyle/>
+          <a:p>
+            <a:pPr algn="ctr"/>
+          </a:p>
+        </p:txBody>
+      </p:sp>
+      <p:sp>
+        <p:nvSpPr>
+          <p:cNvPr id="3" name="TextBox 2"/>
+          <p:cNvSpPr txBox="1"/>
+          <p:nvPr/>
+        </p:nvSpPr>
+        <p:spPr>
+          <a:xfrm>
+            <a:off x="182880" y="0"/>
+            <a:ext cx="8229600" cy="685800"/>
+          </a:xfrm>
+          <a:prstGeom prst="rect">
+            <a:avLst/>
+          </a:prstGeom>
+          <a:noFill/>
+        </p:spPr>
+        <p:txBody>
+          <a:bodyPr wrap="square">
+            <a:spAutoFit/>
+          </a:bodyPr>
+          <a:lstStyle/>
+          <a:p>
+            <a:r>
+              <a:rPr sz="2400" b="1">
+                <a:solidFill>
+                  <a:srgbClr val="FFFFFF"/>
+                </a:solidFill>
+              </a:rPr>
+              <a:t>03  |  Autoencoder + K-Means</a:t>
+            </a:r>
+          </a:p>
+        </p:txBody>
+      </p:sp>
       <p:pic>
         <p:nvPicPr>
-          <p:cNvPr id="2" name="Picture 1" descr="exec_slide_03_autoencoder_kmeans.png"/>
+          <p:cNvPr id="4" name="Picture 3" descr="03_autoencoder.png"/>
           <p:cNvPicPr>
             <a:picLocks noChangeAspect="1"/>
           </p:cNvPicPr>
@@ -3239,14 +4500,319 @@
         </p:blipFill>
         <p:spPr>
           <a:xfrm>
-            <a:off x="0" y="0"/>
-            <a:ext cx="12188952" cy="6858000"/>
+            <a:off x="182880" y="777240"/>
+            <a:ext cx="7863840" cy="5852160"/>
           </a:xfrm>
           <a:prstGeom prst="rect">
             <a:avLst/>
           </a:prstGeom>
         </p:spPr>
       </p:pic>
+      <p:sp>
+        <p:nvSpPr>
+          <p:cNvPr id="5" name="Rectangle 4"/>
+          <p:cNvSpPr/>
+          <p:nvPr/>
+        </p:nvSpPr>
+        <p:spPr>
+          <a:xfrm>
+            <a:off x="8275320" y="777240"/>
+            <a:ext cx="3730752" cy="5852160"/>
+          </a:xfrm>
+          <a:prstGeom prst="rect">
+            <a:avLst/>
+          </a:prstGeom>
+          <a:solidFill>
+            <a:srgbClr val="F3E5F5"/>
+          </a:solidFill>
+          <a:ln w="12700">
+            <a:solidFill>
+              <a:srgbClr val="CE93D8"/>
+            </a:solidFill>
+          </a:ln>
+        </p:spPr>
+        <p:style>
+          <a:lnRef idx="1">
+            <a:schemeClr val="accent1"/>
+          </a:lnRef>
+          <a:fillRef idx="3">
+            <a:schemeClr val="accent1"/>
+          </a:fillRef>
+          <a:effectRef idx="2">
+            <a:schemeClr val="accent1"/>
+          </a:effectRef>
+          <a:fontRef idx="minor">
+            <a:schemeClr val="lt1"/>
+          </a:fontRef>
+        </p:style>
+        <p:txBody>
+          <a:bodyPr rtlCol="0" anchor="ctr"/>
+          <a:lstStyle/>
+          <a:p>
+            <a:pPr algn="ctr"/>
+          </a:p>
+        </p:txBody>
+      </p:sp>
+      <p:sp>
+        <p:nvSpPr>
+          <p:cNvPr id="6" name="TextBox 5"/>
+          <p:cNvSpPr txBox="1"/>
+          <p:nvPr/>
+        </p:nvSpPr>
+        <p:spPr>
+          <a:xfrm>
+            <a:off x="8366760" y="822960"/>
+            <a:ext cx="3566160" cy="5669280"/>
+          </a:xfrm>
+          <a:prstGeom prst="rect">
+            <a:avLst/>
+          </a:prstGeom>
+          <a:noFill/>
+        </p:spPr>
+        <p:txBody>
+          <a:bodyPr wrap="square">
+            <a:spAutoFit/>
+          </a:bodyPr>
+          <a:lstStyle/>
+          <a:p>
+            <a:r>
+              <a:rPr sz="1100">
+                <a:solidFill>
+                  <a:srgbClr val="280A3C"/>
+                </a:solidFill>
+              </a:rPr>
+              <a:t>Algorithm Summary</a:t>
+            </a:r>
+          </a:p>
+          <a:p/>
+          <a:p>
+            <a:r>
+              <a:rPr sz="1100">
+                <a:solidFill>
+                  <a:srgbClr val="280A3C"/>
+                </a:solidFill>
+              </a:rPr>
+              <a:t>Category: Deep Learning</a:t>
+            </a:r>
+          </a:p>
+          <a:p/>
+          <a:p>
+            <a:r>
+              <a:rPr sz="1100">
+                <a:solidFill>
+                  <a:srgbClr val="280A3C"/>
+                </a:solidFill>
+              </a:rPr>
+              <a:t>Core Idea</a:t>
+            </a:r>
+          </a:p>
+          <a:p>
+            <a:r>
+              <a:rPr sz="1100">
+                <a:solidFill>
+                  <a:srgbClr val="280A3C"/>
+                </a:solidFill>
+              </a:rPr>
+              <a:t>126D 레이아웃 피처를 16D latent space로 압축 후 K-Means 적용. 비선형 구조 포착.</a:t>
+            </a:r>
+          </a:p>
+          <a:p/>
+          <a:p>
+            <a:r>
+              <a:rPr sz="1100">
+                <a:solidFill>
+                  <a:srgbClr val="280A3C"/>
+                </a:solidFill>
+              </a:rPr>
+              <a:t>Architecture</a:t>
+            </a:r>
+          </a:p>
+          <a:p>
+            <a:r>
+              <a:rPr sz="1100">
+                <a:solidFill>
+                  <a:srgbClr val="280A3C"/>
+                </a:solidFill>
+              </a:rPr>
+              <a:t>Input(126) → 128 → 64 → 32</a:t>
+            </a:r>
+          </a:p>
+          <a:p>
+            <a:r>
+              <a:rPr sz="1100">
+                <a:solidFill>
+                  <a:srgbClr val="280A3C"/>
+                </a:solidFill>
+              </a:rPr>
+              <a:t>→ Latent z (16D) ← K-Means</a:t>
+            </a:r>
+          </a:p>
+          <a:p>
+            <a:r>
+              <a:rPr sz="1100">
+                <a:solidFill>
+                  <a:srgbClr val="280A3C"/>
+                </a:solidFill>
+              </a:rPr>
+              <a:t>→ 32 → 64 → 128 → Output(126)</a:t>
+            </a:r>
+          </a:p>
+          <a:p>
+            <a:r>
+              <a:rPr sz="1100">
+                <a:solidFill>
+                  <a:srgbClr val="280A3C"/>
+                </a:solidFill>
+              </a:rPr>
+              <a:t>· BatchNorm + LeakyReLU</a:t>
+            </a:r>
+          </a:p>
+          <a:p>
+            <a:r>
+              <a:rPr sz="1100">
+                <a:solidFill>
+                  <a:srgbClr val="280A3C"/>
+                </a:solidFill>
+              </a:rPr>
+              <a:t>· Loss: MSE reconstruction</a:t>
+            </a:r>
+          </a:p>
+          <a:p/>
+          <a:p>
+            <a:r>
+              <a:rPr sz="1100">
+                <a:solidFill>
+                  <a:srgbClr val="280A3C"/>
+                </a:solidFill>
+              </a:rPr>
+              <a:t>Training</a:t>
+            </a:r>
+          </a:p>
+          <a:p>
+            <a:r>
+              <a:rPr sz="1100">
+                <a:solidFill>
+                  <a:srgbClr val="280A3C"/>
+                </a:solidFill>
+              </a:rPr>
+              <a:t>① AE를 reconstruction loss로 학습</a:t>
+            </a:r>
+          </a:p>
+          <a:p>
+            <a:r>
+              <a:rPr sz="1100">
+                <a:solidFill>
+                  <a:srgbClr val="280A3C"/>
+                </a:solidFill>
+              </a:rPr>
+              <a:t>② 전체 데이터 z 벡터 추출</a:t>
+            </a:r>
+          </a:p>
+          <a:p>
+            <a:r>
+              <a:rPr sz="1100">
+                <a:solidFill>
+                  <a:srgbClr val="280A3C"/>
+                </a:solidFill>
+              </a:rPr>
+              <a:t>③ z에 K-Means 적용</a:t>
+            </a:r>
+          </a:p>
+          <a:p/>
+          <a:p>
+            <a:r>
+              <a:rPr sz="1100">
+                <a:solidFill>
+                  <a:srgbClr val="280A3C"/>
+                </a:solidFill>
+              </a:rPr>
+              <a:t>Dimensionality</a:t>
+            </a:r>
+          </a:p>
+          <a:p>
+            <a:r>
+              <a:rPr sz="1100">
+                <a:solidFill>
+                  <a:srgbClr val="280A3C"/>
+                </a:solidFill>
+              </a:rPr>
+              <a:t>126D → 16D (87% 압축)</a:t>
+            </a:r>
+          </a:p>
+          <a:p/>
+          <a:p>
+            <a:r>
+              <a:rPr sz="1100">
+                <a:solidFill>
+                  <a:srgbClr val="280A3C"/>
+                </a:solidFill>
+              </a:rPr>
+              <a:t>Properties</a:t>
+            </a:r>
+          </a:p>
+          <a:p>
+            <a:r>
+              <a:rPr sz="1100">
+                <a:solidFill>
+                  <a:srgbClr val="280A3C"/>
+                </a:solidFill>
+              </a:rPr>
+              <a:t>✓ 비선형 manifold 구조 포착</a:t>
+            </a:r>
+          </a:p>
+          <a:p>
+            <a:r>
+              <a:rPr sz="1100">
+                <a:solidFill>
+                  <a:srgbClr val="280A3C"/>
+                </a:solidFill>
+              </a:rPr>
+              <a:t>✓ GPU 가속 학습</a:t>
+            </a:r>
+          </a:p>
+          <a:p>
+            <a:r>
+              <a:rPr sz="1100">
+                <a:solidFill>
+                  <a:srgbClr val="280A3C"/>
+                </a:solidFill>
+              </a:rPr>
+              <a:t>✓ t-SNE 시각화로 클러스터 확인</a:t>
+            </a:r>
+          </a:p>
+          <a:p/>
+          <a:p>
+            <a:r>
+              <a:rPr sz="1100">
+                <a:solidFill>
+                  <a:srgbClr val="280A3C"/>
+                </a:solidFill>
+              </a:rPr>
+              <a:t>Reference</a:t>
+            </a:r>
+          </a:p>
+          <a:p>
+            <a:r>
+              <a:rPr sz="1100">
+                <a:solidFill>
+                  <a:srgbClr val="280A3C"/>
+                </a:solidFill>
+              </a:rPr>
+              <a:t>Hinton &amp; Salakhutdinov (2006)</a:t>
+            </a:r>
+          </a:p>
+          <a:p>
+            <a:r>
+              <a:rPr sz="1100">
+                <a:solidFill>
+                  <a:srgbClr val="280A3C"/>
+                </a:solidFill>
+              </a:rPr>
+              <a:t>Xie et al., DEC, ICML 2016</a:t>
+            </a:r>
+          </a:p>
+        </p:txBody>
+      </p:sp>
     </p:spTree>
   </p:cSld>
   <p:clrMapOvr>
@@ -3265,9 +4831,87 @@
         <p:nvPr/>
       </p:nvGrpSpPr>
       <p:grpSpPr/>
+      <p:sp>
+        <p:nvSpPr>
+          <p:cNvPr id="2" name="Rectangle 1"/>
+          <p:cNvSpPr/>
+          <p:nvPr/>
+        </p:nvSpPr>
+        <p:spPr>
+          <a:xfrm>
+            <a:off x="0" y="0"/>
+            <a:ext cx="12188952" cy="685800"/>
+          </a:xfrm>
+          <a:prstGeom prst="rect">
+            <a:avLst/>
+          </a:prstGeom>
+          <a:solidFill>
+            <a:srgbClr val="E65100"/>
+          </a:solidFill>
+          <a:ln>
+            <a:solidFill>
+              <a:srgbClr val="E65100"/>
+            </a:solidFill>
+          </a:ln>
+        </p:spPr>
+        <p:style>
+          <a:lnRef idx="1">
+            <a:schemeClr val="accent1"/>
+          </a:lnRef>
+          <a:fillRef idx="3">
+            <a:schemeClr val="accent1"/>
+          </a:fillRef>
+          <a:effectRef idx="2">
+            <a:schemeClr val="accent1"/>
+          </a:effectRef>
+          <a:fontRef idx="minor">
+            <a:schemeClr val="lt1"/>
+          </a:fontRef>
+        </p:style>
+        <p:txBody>
+          <a:bodyPr rtlCol="0" anchor="ctr"/>
+          <a:lstStyle/>
+          <a:p>
+            <a:pPr algn="ctr"/>
+          </a:p>
+        </p:txBody>
+      </p:sp>
+      <p:sp>
+        <p:nvSpPr>
+          <p:cNvPr id="3" name="TextBox 2"/>
+          <p:cNvSpPr txBox="1"/>
+          <p:nvPr/>
+        </p:nvSpPr>
+        <p:spPr>
+          <a:xfrm>
+            <a:off x="182880" y="0"/>
+            <a:ext cx="8229600" cy="685800"/>
+          </a:xfrm>
+          <a:prstGeom prst="rect">
+            <a:avLst/>
+          </a:prstGeom>
+          <a:noFill/>
+        </p:spPr>
+        <p:txBody>
+          <a:bodyPr wrap="square">
+            <a:spAutoFit/>
+          </a:bodyPr>
+          <a:lstStyle/>
+          <a:p>
+            <a:r>
+              <a:rPr sz="2400" b="1">
+                <a:solidFill>
+                  <a:srgbClr val="FFFFFF"/>
+                </a:solidFill>
+              </a:rPr>
+              <a:t>04  |  Gaussian Mixture Model  (GMM)</a:t>
+            </a:r>
+          </a:p>
+        </p:txBody>
+      </p:sp>
       <p:pic>
         <p:nvPicPr>
-          <p:cNvPr id="2" name="Picture 1" descr="exec_slide_04_gmm.png"/>
+          <p:cNvPr id="4" name="Picture 3" descr="04_gmm.png"/>
           <p:cNvPicPr>
             <a:picLocks noChangeAspect="1"/>
           </p:cNvPicPr>
@@ -3281,14 +4925,319 @@
         </p:blipFill>
         <p:spPr>
           <a:xfrm>
-            <a:off x="0" y="0"/>
-            <a:ext cx="12188952" cy="6858000"/>
+            <a:off x="182880" y="777240"/>
+            <a:ext cx="7863840" cy="5852160"/>
           </a:xfrm>
           <a:prstGeom prst="rect">
             <a:avLst/>
           </a:prstGeom>
         </p:spPr>
       </p:pic>
+      <p:sp>
+        <p:nvSpPr>
+          <p:cNvPr id="5" name="Rectangle 4"/>
+          <p:cNvSpPr/>
+          <p:nvPr/>
+        </p:nvSpPr>
+        <p:spPr>
+          <a:xfrm>
+            <a:off x="8275320" y="777240"/>
+            <a:ext cx="3730752" cy="5852160"/>
+          </a:xfrm>
+          <a:prstGeom prst="rect">
+            <a:avLst/>
+          </a:prstGeom>
+          <a:solidFill>
+            <a:srgbClr val="FFF3E0"/>
+          </a:solidFill>
+          <a:ln w="12700">
+            <a:solidFill>
+              <a:srgbClr val="FFCC80"/>
+            </a:solidFill>
+          </a:ln>
+        </p:spPr>
+        <p:style>
+          <a:lnRef idx="1">
+            <a:schemeClr val="accent1"/>
+          </a:lnRef>
+          <a:fillRef idx="3">
+            <a:schemeClr val="accent1"/>
+          </a:fillRef>
+          <a:effectRef idx="2">
+            <a:schemeClr val="accent1"/>
+          </a:effectRef>
+          <a:fontRef idx="minor">
+            <a:schemeClr val="lt1"/>
+          </a:fontRef>
+        </p:style>
+        <p:txBody>
+          <a:bodyPr rtlCol="0" anchor="ctr"/>
+          <a:lstStyle/>
+          <a:p>
+            <a:pPr algn="ctr"/>
+          </a:p>
+        </p:txBody>
+      </p:sp>
+      <p:sp>
+        <p:nvSpPr>
+          <p:cNvPr id="6" name="TextBox 5"/>
+          <p:cNvSpPr txBox="1"/>
+          <p:nvPr/>
+        </p:nvSpPr>
+        <p:spPr>
+          <a:xfrm>
+            <a:off x="8366760" y="822960"/>
+            <a:ext cx="3566160" cy="5669280"/>
+          </a:xfrm>
+          <a:prstGeom prst="rect">
+            <a:avLst/>
+          </a:prstGeom>
+          <a:noFill/>
+        </p:spPr>
+        <p:txBody>
+          <a:bodyPr wrap="square">
+            <a:spAutoFit/>
+          </a:bodyPr>
+          <a:lstStyle/>
+          <a:p>
+            <a:r>
+              <a:rPr sz="1100">
+                <a:solidFill>
+                  <a:srgbClr val="3C1400"/>
+                </a:solidFill>
+              </a:rPr>
+              <a:t>Algorithm Summary</a:t>
+            </a:r>
+          </a:p>
+          <a:p/>
+          <a:p>
+            <a:r>
+              <a:rPr sz="1100">
+                <a:solidFill>
+                  <a:srgbClr val="3C1400"/>
+                </a:solidFill>
+              </a:rPr>
+              <a:t>Category: Probabilistic</a:t>
+            </a:r>
+          </a:p>
+          <a:p/>
+          <a:p>
+            <a:r>
+              <a:rPr sz="1100">
+                <a:solidFill>
+                  <a:srgbClr val="3C1400"/>
+                </a:solidFill>
+              </a:rPr>
+              <a:t>Core Idea</a:t>
+            </a:r>
+          </a:p>
+          <a:p>
+            <a:r>
+              <a:rPr sz="1100">
+                <a:solidFill>
+                  <a:srgbClr val="3C1400"/>
+                </a:solidFill>
+              </a:rPr>
+              <a:t>데이터를 K개 가우시안 분포의 혼합으로 모델링. Soft(확률적) 소속 부여.</a:t>
+            </a:r>
+          </a:p>
+          <a:p/>
+          <a:p>
+            <a:r>
+              <a:rPr sz="1100">
+                <a:solidFill>
+                  <a:srgbClr val="3C1400"/>
+                </a:solidFill>
+              </a:rPr>
+              <a:t>Model</a:t>
+            </a:r>
+          </a:p>
+          <a:p>
+            <a:r>
+              <a:rPr sz="1100">
+                <a:solidFill>
+                  <a:srgbClr val="3C1400"/>
+                </a:solidFill>
+              </a:rPr>
+              <a:t>p(x) = Σ πₖ N(x | μₖ, Σₖ)</a:t>
+            </a:r>
+          </a:p>
+          <a:p>
+            <a:r>
+              <a:rPr sz="1100">
+                <a:solidFill>
+                  <a:srgbClr val="3C1400"/>
+                </a:solidFill>
+              </a:rPr>
+              <a:t>· πₖ: 혼합 가중치</a:t>
+            </a:r>
+          </a:p>
+          <a:p>
+            <a:r>
+              <a:rPr sz="1100">
+                <a:solidFill>
+                  <a:srgbClr val="3C1400"/>
+                </a:solidFill>
+              </a:rPr>
+              <a:t>· μₖ: 클러스터 평균</a:t>
+            </a:r>
+          </a:p>
+          <a:p>
+            <a:r>
+              <a:rPr sz="1100">
+                <a:solidFill>
+                  <a:srgbClr val="3C1400"/>
+                </a:solidFill>
+              </a:rPr>
+              <a:t>· Σₖ: 공분산 행렬 (full)</a:t>
+            </a:r>
+          </a:p>
+          <a:p/>
+          <a:p>
+            <a:r>
+              <a:rPr sz="1100">
+                <a:solidFill>
+                  <a:srgbClr val="3C1400"/>
+                </a:solidFill>
+              </a:rPr>
+              <a:t>EM Algorithm</a:t>
+            </a:r>
+          </a:p>
+          <a:p>
+            <a:r>
+              <a:rPr sz="1100">
+                <a:solidFill>
+                  <a:srgbClr val="3C1400"/>
+                </a:solidFill>
+              </a:rPr>
+              <a:t>① E-step: responsibility rᵢₖ 계산</a:t>
+            </a:r>
+          </a:p>
+          <a:p>
+            <a:r>
+              <a:rPr sz="1100">
+                <a:solidFill>
+                  <a:srgbClr val="3C1400"/>
+                </a:solidFill>
+              </a:rPr>
+              <a:t>② M-step: μ, Σ, π 업데이트</a:t>
+            </a:r>
+          </a:p>
+          <a:p>
+            <a:r>
+              <a:rPr sz="1100">
+                <a:solidFill>
+                  <a:srgbClr val="3C1400"/>
+                </a:solidFill>
+              </a:rPr>
+              <a:t>③ log-likelihood 수렴까지 반복</a:t>
+            </a:r>
+          </a:p>
+          <a:p/>
+          <a:p>
+            <a:r>
+              <a:rPr sz="1100">
+                <a:solidFill>
+                  <a:srgbClr val="3C1400"/>
+                </a:solidFill>
+              </a:rPr>
+              <a:t>Scalability</a:t>
+            </a:r>
+          </a:p>
+          <a:p>
+            <a:r>
+              <a:rPr sz="1100">
+                <a:solidFill>
+                  <a:srgbClr val="3C1400"/>
+                </a:solidFill>
+              </a:rPr>
+              <a:t>50K 서브샘플 학습 → 전체 예측</a:t>
+            </a:r>
+          </a:p>
+          <a:p/>
+          <a:p>
+            <a:r>
+              <a:rPr sz="1100">
+                <a:solidFill>
+                  <a:srgbClr val="3C1400"/>
+                </a:solidFill>
+              </a:rPr>
+              <a:t>Properties</a:t>
+            </a:r>
+          </a:p>
+          <a:p>
+            <a:r>
+              <a:rPr sz="1100">
+                <a:solidFill>
+                  <a:srgbClr val="3C1400"/>
+                </a:solidFill>
+              </a:rPr>
+              <a:t>✓ Soft assignment (불확실성 정량화)</a:t>
+            </a:r>
+          </a:p>
+          <a:p>
+            <a:r>
+              <a:rPr sz="1100">
+                <a:solidFill>
+                  <a:srgbClr val="3C1400"/>
+                </a:solidFill>
+              </a:rPr>
+              <a:t>✓ 타원형/기울어진 클러스터 처리</a:t>
+            </a:r>
+          </a:p>
+          <a:p>
+            <a:r>
+              <a:rPr sz="1100">
+                <a:solidFill>
+                  <a:srgbClr val="3C1400"/>
+                </a:solidFill>
+              </a:rPr>
+              <a:t>✓ BIC/AIC로 최적 k 선정</a:t>
+            </a:r>
+          </a:p>
+          <a:p>
+            <a:r>
+              <a:rPr sz="1100">
+                <a:solidFill>
+                  <a:srgbClr val="3C1400"/>
+                </a:solidFill>
+              </a:rPr>
+              <a:t>△ EM 수렴 속도 느림</a:t>
+            </a:r>
+          </a:p>
+          <a:p/>
+          <a:p>
+            <a:r>
+              <a:rPr sz="1100">
+                <a:solidFill>
+                  <a:srgbClr val="3C1400"/>
+                </a:solidFill>
+              </a:rPr>
+              <a:t>Reference</a:t>
+            </a:r>
+          </a:p>
+          <a:p>
+            <a:r>
+              <a:rPr sz="1100">
+                <a:solidFill>
+                  <a:srgbClr val="3C1400"/>
+                </a:solidFill>
+              </a:rPr>
+              <a:t>Dempster et al. (1977), JRSS-B</a:t>
+            </a:r>
+          </a:p>
+          <a:p>
+            <a:r>
+              <a:rPr sz="1100">
+                <a:solidFill>
+                  <a:srgbClr val="3C1400"/>
+                </a:solidFill>
+              </a:rPr>
+              <a:t>Reynolds (2009), Encyclopedia</a:t>
+            </a:r>
+          </a:p>
+        </p:txBody>
+      </p:sp>
     </p:spTree>
   </p:cSld>
   <p:clrMapOvr>
@@ -3307,9 +5256,87 @@
         <p:nvPr/>
       </p:nvGrpSpPr>
       <p:grpSpPr/>
+      <p:sp>
+        <p:nvSpPr>
+          <p:cNvPr id="2" name="Rectangle 1"/>
+          <p:cNvSpPr/>
+          <p:nvPr/>
+        </p:nvSpPr>
+        <p:spPr>
+          <a:xfrm>
+            <a:off x="0" y="0"/>
+            <a:ext cx="12188952" cy="685800"/>
+          </a:xfrm>
+          <a:prstGeom prst="rect">
+            <a:avLst/>
+          </a:prstGeom>
+          <a:solidFill>
+            <a:srgbClr val="00838F"/>
+          </a:solidFill>
+          <a:ln>
+            <a:solidFill>
+              <a:srgbClr val="00838F"/>
+            </a:solidFill>
+          </a:ln>
+        </p:spPr>
+        <p:style>
+          <a:lnRef idx="1">
+            <a:schemeClr val="accent1"/>
+          </a:lnRef>
+          <a:fillRef idx="3">
+            <a:schemeClr val="accent1"/>
+          </a:fillRef>
+          <a:effectRef idx="2">
+            <a:schemeClr val="accent1"/>
+          </a:effectRef>
+          <a:fontRef idx="minor">
+            <a:schemeClr val="lt1"/>
+          </a:fontRef>
+        </p:style>
+        <p:txBody>
+          <a:bodyPr rtlCol="0" anchor="ctr"/>
+          <a:lstStyle/>
+          <a:p>
+            <a:pPr algn="ctr"/>
+          </a:p>
+        </p:txBody>
+      </p:sp>
+      <p:sp>
+        <p:nvSpPr>
+          <p:cNvPr id="3" name="TextBox 2"/>
+          <p:cNvSpPr txBox="1"/>
+          <p:nvPr/>
+        </p:nvSpPr>
+        <p:spPr>
+          <a:xfrm>
+            <a:off x="182880" y="0"/>
+            <a:ext cx="8229600" cy="685800"/>
+          </a:xfrm>
+          <a:prstGeom prst="rect">
+            <a:avLst/>
+          </a:prstGeom>
+          <a:noFill/>
+        </p:spPr>
+        <p:txBody>
+          <a:bodyPr wrap="square">
+            <a:spAutoFit/>
+          </a:bodyPr>
+          <a:lstStyle/>
+          <a:p>
+            <a:r>
+              <a:rPr sz="2400" b="1">
+                <a:solidFill>
+                  <a:srgbClr val="FFFFFF"/>
+                </a:solidFill>
+              </a:rPr>
+              <a:t>05  |  Bisecting K-Means</a:t>
+            </a:r>
+          </a:p>
+        </p:txBody>
+      </p:sp>
       <p:pic>
         <p:nvPicPr>
-          <p:cNvPr id="2" name="Picture 1" descr="exec_slide_05_bisecting_kmeans.png"/>
+          <p:cNvPr id="4" name="Picture 3" descr="02_bisecting_kmeans.png"/>
           <p:cNvPicPr>
             <a:picLocks noChangeAspect="1"/>
           </p:cNvPicPr>
@@ -3323,14 +5350,319 @@
         </p:blipFill>
         <p:spPr>
           <a:xfrm>
-            <a:off x="0" y="0"/>
-            <a:ext cx="12188952" cy="6858000"/>
+            <a:off x="182880" y="777240"/>
+            <a:ext cx="7863840" cy="5852160"/>
           </a:xfrm>
           <a:prstGeom prst="rect">
             <a:avLst/>
           </a:prstGeom>
         </p:spPr>
       </p:pic>
+      <p:sp>
+        <p:nvSpPr>
+          <p:cNvPr id="5" name="Rectangle 4"/>
+          <p:cNvSpPr/>
+          <p:nvPr/>
+        </p:nvSpPr>
+        <p:spPr>
+          <a:xfrm>
+            <a:off x="8275320" y="777240"/>
+            <a:ext cx="3730752" cy="5852160"/>
+          </a:xfrm>
+          <a:prstGeom prst="rect">
+            <a:avLst/>
+          </a:prstGeom>
+          <a:solidFill>
+            <a:srgbClr val="E0F7FA"/>
+          </a:solidFill>
+          <a:ln w="12700">
+            <a:solidFill>
+              <a:srgbClr val="80DEEA"/>
+            </a:solidFill>
+          </a:ln>
+        </p:spPr>
+        <p:style>
+          <a:lnRef idx="1">
+            <a:schemeClr val="accent1"/>
+          </a:lnRef>
+          <a:fillRef idx="3">
+            <a:schemeClr val="accent1"/>
+          </a:fillRef>
+          <a:effectRef idx="2">
+            <a:schemeClr val="accent1"/>
+          </a:effectRef>
+          <a:fontRef idx="minor">
+            <a:schemeClr val="lt1"/>
+          </a:fontRef>
+        </p:style>
+        <p:txBody>
+          <a:bodyPr rtlCol="0" anchor="ctr"/>
+          <a:lstStyle/>
+          <a:p>
+            <a:pPr algn="ctr"/>
+          </a:p>
+        </p:txBody>
+      </p:sp>
+      <p:sp>
+        <p:nvSpPr>
+          <p:cNvPr id="6" name="TextBox 5"/>
+          <p:cNvSpPr txBox="1"/>
+          <p:nvPr/>
+        </p:nvSpPr>
+        <p:spPr>
+          <a:xfrm>
+            <a:off x="8366760" y="822960"/>
+            <a:ext cx="3566160" cy="5669280"/>
+          </a:xfrm>
+          <a:prstGeom prst="rect">
+            <a:avLst/>
+          </a:prstGeom>
+          <a:noFill/>
+        </p:spPr>
+        <p:txBody>
+          <a:bodyPr wrap="square">
+            <a:spAutoFit/>
+          </a:bodyPr>
+          <a:lstStyle/>
+          <a:p>
+            <a:r>
+              <a:rPr sz="1100">
+                <a:solidFill>
+                  <a:srgbClr val="002832"/>
+                </a:solidFill>
+              </a:rPr>
+              <a:t>Algorithm Summary</a:t>
+            </a:r>
+          </a:p>
+          <a:p/>
+          <a:p>
+            <a:r>
+              <a:rPr sz="1100">
+                <a:solidFill>
+                  <a:srgbClr val="002832"/>
+                </a:solidFill>
+              </a:rPr>
+              <a:t>Category: Divisive Hierarchical</a:t>
+            </a:r>
+          </a:p>
+          <a:p/>
+          <a:p>
+            <a:r>
+              <a:rPr sz="1100">
+                <a:solidFill>
+                  <a:srgbClr val="002832"/>
+                </a:solidFill>
+              </a:rPr>
+              <a:t>Core Idea</a:t>
+            </a:r>
+          </a:p>
+          <a:p>
+            <a:r>
+              <a:rPr sz="1100">
+                <a:solidFill>
+                  <a:srgbClr val="002832"/>
+                </a:solidFill>
+              </a:rPr>
+              <a:t>Top-down 방식: 전체 데이터 1개 클러스터에서 시작해 SSE 최대 클러스터를 반복 이분(bisect).</a:t>
+            </a:r>
+          </a:p>
+          <a:p/>
+          <a:p>
+            <a:r>
+              <a:rPr sz="1100">
+                <a:solidFill>
+                  <a:srgbClr val="002832"/>
+                </a:solidFill>
+              </a:rPr>
+              <a:t>Algorithm</a:t>
+            </a:r>
+          </a:p>
+          <a:p>
+            <a:r>
+              <a:rPr sz="1100">
+                <a:solidFill>
+                  <a:srgbClr val="002832"/>
+                </a:solidFill>
+              </a:rPr>
+              <a:t>① 전체 데이터 = 클러스터 C₀</a:t>
+            </a:r>
+          </a:p>
+          <a:p>
+            <a:r>
+              <a:rPr sz="1100">
+                <a:solidFill>
+                  <a:srgbClr val="002832"/>
+                </a:solidFill>
+              </a:rPr>
+              <a:t>② SSE 최대 클러스터 C* 선택</a:t>
+            </a:r>
+          </a:p>
+          <a:p>
+            <a:r>
+              <a:rPr sz="1100">
+                <a:solidFill>
+                  <a:srgbClr val="002832"/>
+                </a:solidFill>
+              </a:rPr>
+              <a:t>③ K-Means(k=2)로 C* 분할</a:t>
+            </a:r>
+          </a:p>
+          <a:p>
+            <a:r>
+              <a:rPr sz="1100">
+                <a:solidFill>
+                  <a:srgbClr val="002832"/>
+                </a:solidFill>
+              </a:rPr>
+              <a:t>   → C_a, C_b</a:t>
+            </a:r>
+          </a:p>
+          <a:p>
+            <a:r>
+              <a:rPr sz="1100">
+                <a:solidFill>
+                  <a:srgbClr val="002832"/>
+                </a:solidFill>
+              </a:rPr>
+              <a:t>④ k개 클러스터 달성까지 반복</a:t>
+            </a:r>
+          </a:p>
+          <a:p/>
+          <a:p>
+            <a:r>
+              <a:rPr sz="1100">
+                <a:solidFill>
+                  <a:srgbClr val="002832"/>
+                </a:solidFill>
+              </a:rPr>
+              <a:t>Split Criterion</a:t>
+            </a:r>
+          </a:p>
+          <a:p>
+            <a:r>
+              <a:rPr sz="1100">
+                <a:solidFill>
+                  <a:srgbClr val="002832"/>
+                </a:solidFill>
+              </a:rPr>
+              <a:t>C* = argmax SSE(Cⱼ)</a:t>
+            </a:r>
+          </a:p>
+          <a:p>
+            <a:r>
+              <a:rPr sz="1100">
+                <a:solidFill>
+                  <a:srgbClr val="002832"/>
+                </a:solidFill>
+              </a:rPr>
+              <a:t>SSE(C) = Σ ‖x − μ_C‖²</a:t>
+            </a:r>
+          </a:p>
+          <a:p/>
+          <a:p>
+            <a:r>
+              <a:rPr sz="1100">
+                <a:solidFill>
+                  <a:srgbClr val="002832"/>
+                </a:solidFill>
+              </a:rPr>
+              <a:t>vs Regular K-Means</a:t>
+            </a:r>
+          </a:p>
+          <a:p>
+            <a:r>
+              <a:rPr sz="1100">
+                <a:solidFill>
+                  <a:srgbClr val="002832"/>
+                </a:solidFill>
+              </a:rPr>
+              <a:t>• Flat K-Means: 전체 동시 최적화</a:t>
+            </a:r>
+          </a:p>
+          <a:p>
+            <a:r>
+              <a:rPr sz="1100">
+                <a:solidFill>
+                  <a:srgbClr val="002832"/>
+                </a:solidFill>
+              </a:rPr>
+              <a:t>• Bisecting: 국소적 이분 → 균형적</a:t>
+            </a:r>
+          </a:p>
+          <a:p/>
+          <a:p>
+            <a:r>
+              <a:rPr sz="1100">
+                <a:solidFill>
+                  <a:srgbClr val="002832"/>
+                </a:solidFill>
+              </a:rPr>
+              <a:t>Properties</a:t>
+            </a:r>
+          </a:p>
+          <a:p>
+            <a:r>
+              <a:rPr sz="1100">
+                <a:solidFill>
+                  <a:srgbClr val="002832"/>
+                </a:solidFill>
+              </a:rPr>
+              <a:t>✓ Regular K-Means보다 균형 잡힌 분할</a:t>
+            </a:r>
+          </a:p>
+          <a:p>
+            <a:r>
+              <a:rPr sz="1100">
+                <a:solidFill>
+                  <a:srgbClr val="002832"/>
+                </a:solidFill>
+              </a:rPr>
+              <a:t>✓ 암묵적 이진 트리 생성</a:t>
+            </a:r>
+          </a:p>
+          <a:p>
+            <a:r>
+              <a:rPr sz="1100">
+                <a:solidFill>
+                  <a:srgbClr val="002832"/>
+                </a:solidFill>
+              </a:rPr>
+              <a:t>✓ O(k·n·d) 복잡도</a:t>
+            </a:r>
+          </a:p>
+          <a:p>
+            <a:r>
+              <a:rPr sz="1100">
+                <a:solidFill>
+                  <a:srgbClr val="002832"/>
+                </a:solidFill>
+              </a:rPr>
+              <a:t>✓ 초기화 민감도 낮음</a:t>
+            </a:r>
+          </a:p>
+          <a:p/>
+          <a:p>
+            <a:r>
+              <a:rPr sz="1100">
+                <a:solidFill>
+                  <a:srgbClr val="002832"/>
+                </a:solidFill>
+              </a:rPr>
+              <a:t>Reference</a:t>
+            </a:r>
+          </a:p>
+          <a:p>
+            <a:r>
+              <a:rPr sz="1100">
+                <a:solidFill>
+                  <a:srgbClr val="002832"/>
+                </a:solidFill>
+              </a:rPr>
+              <a:t>Steinbach et al. (2000), KDD Workshop</a:t>
+            </a:r>
+          </a:p>
+        </p:txBody>
+      </p:sp>
     </p:spTree>
   </p:cSld>
   <p:clrMapOvr>
@@ -3349,9 +5681,87 @@
         <p:nvPr/>
       </p:nvGrpSpPr>
       <p:grpSpPr/>
+      <p:sp>
+        <p:nvSpPr>
+          <p:cNvPr id="2" name="Rectangle 1"/>
+          <p:cNvSpPr/>
+          <p:nvPr/>
+        </p:nvSpPr>
+        <p:spPr>
+          <a:xfrm>
+            <a:off x="0" y="0"/>
+            <a:ext cx="12188952" cy="685800"/>
+          </a:xfrm>
+          <a:prstGeom prst="rect">
+            <a:avLst/>
+          </a:prstGeom>
+          <a:solidFill>
+            <a:srgbClr val="C62828"/>
+          </a:solidFill>
+          <a:ln>
+            <a:solidFill>
+              <a:srgbClr val="C62828"/>
+            </a:solidFill>
+          </a:ln>
+        </p:spPr>
+        <p:style>
+          <a:lnRef idx="1">
+            <a:schemeClr val="accent1"/>
+          </a:lnRef>
+          <a:fillRef idx="3">
+            <a:schemeClr val="accent1"/>
+          </a:fillRef>
+          <a:effectRef idx="2">
+            <a:schemeClr val="accent1"/>
+          </a:effectRef>
+          <a:fontRef idx="minor">
+            <a:schemeClr val="lt1"/>
+          </a:fontRef>
+        </p:style>
+        <p:txBody>
+          <a:bodyPr rtlCol="0" anchor="ctr"/>
+          <a:lstStyle/>
+          <a:p>
+            <a:pPr algn="ctr"/>
+          </a:p>
+        </p:txBody>
+      </p:sp>
+      <p:sp>
+        <p:nvSpPr>
+          <p:cNvPr id="3" name="TextBox 2"/>
+          <p:cNvSpPr txBox="1"/>
+          <p:nvPr/>
+        </p:nvSpPr>
+        <p:spPr>
+          <a:xfrm>
+            <a:off x="182880" y="0"/>
+            <a:ext cx="8229600" cy="685800"/>
+          </a:xfrm>
+          <a:prstGeom prst="rect">
+            <a:avLst/>
+          </a:prstGeom>
+          <a:noFill/>
+        </p:spPr>
+        <p:txBody>
+          <a:bodyPr wrap="square">
+            <a:spAutoFit/>
+          </a:bodyPr>
+          <a:lstStyle/>
+          <a:p>
+            <a:r>
+              <a:rPr sz="2000" b="1">
+                <a:solidFill>
+                  <a:srgbClr val="FFFFFF"/>
+                </a:solidFill>
+              </a:rPr>
+              <a:t>06  |  Agglomerative Hierarchical Clustering  (Ward Linkage)</a:t>
+            </a:r>
+          </a:p>
+        </p:txBody>
+      </p:sp>
       <p:pic>
         <p:nvPicPr>
-          <p:cNvPr id="2" name="Picture 1" descr="exec_slide_06_agglomerative_ward.png"/>
+          <p:cNvPr id="4" name="Picture 3" descr="05_agglomerative.png"/>
           <p:cNvPicPr>
             <a:picLocks noChangeAspect="1"/>
           </p:cNvPicPr>
@@ -3365,14 +5775,319 @@
         </p:blipFill>
         <p:spPr>
           <a:xfrm>
-            <a:off x="0" y="0"/>
-            <a:ext cx="12188952" cy="6858000"/>
+            <a:off x="182880" y="777240"/>
+            <a:ext cx="7863840" cy="5852160"/>
           </a:xfrm>
           <a:prstGeom prst="rect">
             <a:avLst/>
           </a:prstGeom>
         </p:spPr>
       </p:pic>
+      <p:sp>
+        <p:nvSpPr>
+          <p:cNvPr id="5" name="Rectangle 4"/>
+          <p:cNvSpPr/>
+          <p:nvPr/>
+        </p:nvSpPr>
+        <p:spPr>
+          <a:xfrm>
+            <a:off x="8275320" y="777240"/>
+            <a:ext cx="3730752" cy="5852160"/>
+          </a:xfrm>
+          <a:prstGeom prst="rect">
+            <a:avLst/>
+          </a:prstGeom>
+          <a:solidFill>
+            <a:srgbClr val="FFEBEE"/>
+          </a:solidFill>
+          <a:ln w="12700">
+            <a:solidFill>
+              <a:srgbClr val="EF9A9A"/>
+            </a:solidFill>
+          </a:ln>
+        </p:spPr>
+        <p:style>
+          <a:lnRef idx="1">
+            <a:schemeClr val="accent1"/>
+          </a:lnRef>
+          <a:fillRef idx="3">
+            <a:schemeClr val="accent1"/>
+          </a:fillRef>
+          <a:effectRef idx="2">
+            <a:schemeClr val="accent1"/>
+          </a:effectRef>
+          <a:fontRef idx="minor">
+            <a:schemeClr val="lt1"/>
+          </a:fontRef>
+        </p:style>
+        <p:txBody>
+          <a:bodyPr rtlCol="0" anchor="ctr"/>
+          <a:lstStyle/>
+          <a:p>
+            <a:pPr algn="ctr"/>
+          </a:p>
+        </p:txBody>
+      </p:sp>
+      <p:sp>
+        <p:nvSpPr>
+          <p:cNvPr id="6" name="TextBox 5"/>
+          <p:cNvSpPr txBox="1"/>
+          <p:nvPr/>
+        </p:nvSpPr>
+        <p:spPr>
+          <a:xfrm>
+            <a:off x="8366760" y="822960"/>
+            <a:ext cx="3566160" cy="5669280"/>
+          </a:xfrm>
+          <a:prstGeom prst="rect">
+            <a:avLst/>
+          </a:prstGeom>
+          <a:noFill/>
+        </p:spPr>
+        <p:txBody>
+          <a:bodyPr wrap="square">
+            <a:spAutoFit/>
+          </a:bodyPr>
+          <a:lstStyle/>
+          <a:p>
+            <a:r>
+              <a:rPr sz="1100">
+                <a:solidFill>
+                  <a:srgbClr val="3C0A0A"/>
+                </a:solidFill>
+              </a:rPr>
+              <a:t>Algorithm Summary</a:t>
+            </a:r>
+          </a:p>
+          <a:p/>
+          <a:p>
+            <a:r>
+              <a:rPr sz="1100">
+                <a:solidFill>
+                  <a:srgbClr val="3C0A0A"/>
+                </a:solidFill>
+              </a:rPr>
+              <a:t>Category: Agglomerative Hierarchical</a:t>
+            </a:r>
+          </a:p>
+          <a:p/>
+          <a:p>
+            <a:r>
+              <a:rPr sz="1100">
+                <a:solidFill>
+                  <a:srgbClr val="3C0A0A"/>
+                </a:solidFill>
+              </a:rPr>
+              <a:t>Core Idea</a:t>
+            </a:r>
+          </a:p>
+          <a:p>
+            <a:r>
+              <a:rPr sz="1100">
+                <a:solidFill>
+                  <a:srgbClr val="3C0A0A"/>
+                </a:solidFill>
+              </a:rPr>
+              <a:t>Bottom-up 병합: 각 포인트를 단독 클러스터로 시작 → Ward 거리 최소 쌍 반복 병합. 전체 덴드로그램 생성.</a:t>
+            </a:r>
+          </a:p>
+          <a:p/>
+          <a:p>
+            <a:r>
+              <a:rPr sz="1100">
+                <a:solidFill>
+                  <a:srgbClr val="3C0A0A"/>
+                </a:solidFill>
+              </a:rPr>
+              <a:t>Ward Linkage</a:t>
+            </a:r>
+          </a:p>
+          <a:p>
+            <a:r>
+              <a:rPr sz="1100">
+                <a:solidFill>
+                  <a:srgbClr val="3C0A0A"/>
+                </a:solidFill>
+              </a:rPr>
+              <a:t>ΔV(i,j) = nᵢnⱼ/(nᵢ+nⱼ) · ‖μᵢ−μⱼ‖²</a:t>
+            </a:r>
+          </a:p>
+          <a:p>
+            <a:r>
+              <a:rPr sz="1100">
+                <a:solidFill>
+                  <a:srgbClr val="3C0A0A"/>
+                </a:solidFill>
+              </a:rPr>
+              <a:t>병합 시 분산 증가량 최소화</a:t>
+            </a:r>
+          </a:p>
+          <a:p/>
+          <a:p>
+            <a:r>
+              <a:rPr sz="1100">
+                <a:solidFill>
+                  <a:srgbClr val="3C0A0A"/>
+                </a:solidFill>
+              </a:rPr>
+              <a:t>Algorithm</a:t>
+            </a:r>
+          </a:p>
+          <a:p>
+            <a:r>
+              <a:rPr sz="1100">
+                <a:solidFill>
+                  <a:srgbClr val="3C0A0A"/>
+                </a:solidFill>
+              </a:rPr>
+              <a:t>① n개 singleton 클러스터 초기화</a:t>
+            </a:r>
+          </a:p>
+          <a:p>
+            <a:r>
+              <a:rPr sz="1100">
+                <a:solidFill>
+                  <a:srgbClr val="3C0A0A"/>
+                </a:solidFill>
+              </a:rPr>
+              <a:t>② Ward 거리 행렬 계산</a:t>
+            </a:r>
+          </a:p>
+          <a:p>
+            <a:r>
+              <a:rPr sz="1100">
+                <a:solidFill>
+                  <a:srgbClr val="3C0A0A"/>
+                </a:solidFill>
+              </a:rPr>
+              <a:t>③ 최소 ΔV 쌍 (Cᵢ, Cⱼ) 병합</a:t>
+            </a:r>
+          </a:p>
+          <a:p>
+            <a:r>
+              <a:rPr sz="1100">
+                <a:solidFill>
+                  <a:srgbClr val="3C0A0A"/>
+                </a:solidFill>
+              </a:rPr>
+              <a:t>④ 거리 행렬 업데이트</a:t>
+            </a:r>
+          </a:p>
+          <a:p>
+            <a:r>
+              <a:rPr sz="1100">
+                <a:solidFill>
+                  <a:srgbClr val="3C0A0A"/>
+                </a:solidFill>
+              </a:rPr>
+              <a:t>⑤ 1개 클러스터 남을 때까지 반복</a:t>
+            </a:r>
+          </a:p>
+          <a:p>
+            <a:r>
+              <a:rPr sz="1100">
+                <a:solidFill>
+                  <a:srgbClr val="3C0A0A"/>
+                </a:solidFill>
+              </a:rPr>
+              <a:t>⑥ 덴드로그램 cut → k개 평탄화</a:t>
+            </a:r>
+          </a:p>
+          <a:p/>
+          <a:p>
+            <a:r>
+              <a:rPr sz="1100">
+                <a:solidFill>
+                  <a:srgbClr val="3C0A0A"/>
+                </a:solidFill>
+              </a:rPr>
+              <a:t>Dendrogram</a:t>
+            </a:r>
+          </a:p>
+          <a:p>
+            <a:r>
+              <a:rPr sz="1100">
+                <a:solidFill>
+                  <a:srgbClr val="3C0A0A"/>
+                </a:solidFill>
+              </a:rPr>
+              <a:t>수직 절단선 위치 = 클러스터 수 결정</a:t>
+            </a:r>
+          </a:p>
+          <a:p/>
+          <a:p>
+            <a:r>
+              <a:rPr sz="1100">
+                <a:solidFill>
+                  <a:srgbClr val="3C0A0A"/>
+                </a:solidFill>
+              </a:rPr>
+              <a:t>Properties</a:t>
+            </a:r>
+          </a:p>
+          <a:p>
+            <a:r>
+              <a:rPr sz="1100">
+                <a:solidFill>
+                  <a:srgbClr val="3C0A0A"/>
+                </a:solidFill>
+              </a:rPr>
+              <a:t>✓ 결정론적 (랜덤 초기화 없음)</a:t>
+            </a:r>
+          </a:p>
+          <a:p>
+            <a:r>
+              <a:rPr sz="1100">
+                <a:solidFill>
+                  <a:srgbClr val="3C0A0A"/>
+                </a:solidFill>
+              </a:rPr>
+              <a:t>✓ 전체 계층 구조 시각화 가능</a:t>
+            </a:r>
+          </a:p>
+          <a:p>
+            <a:r>
+              <a:rPr sz="1100">
+                <a:solidFill>
+                  <a:srgbClr val="3C0A0A"/>
+                </a:solidFill>
+              </a:rPr>
+              <a:t>✓ 균일하고 컴팩트한 클러스터</a:t>
+            </a:r>
+          </a:p>
+          <a:p>
+            <a:r>
+              <a:rPr sz="1100">
+                <a:solidFill>
+                  <a:srgbClr val="3C0A0A"/>
+                </a:solidFill>
+              </a:rPr>
+              <a:t>△ O(n²logn) 메모리</a:t>
+            </a:r>
+          </a:p>
+          <a:p/>
+          <a:p>
+            <a:r>
+              <a:rPr sz="1100">
+                <a:solidFill>
+                  <a:srgbClr val="3C0A0A"/>
+                </a:solidFill>
+              </a:rPr>
+              <a:t>Reference</a:t>
+            </a:r>
+          </a:p>
+          <a:p>
+            <a:r>
+              <a:rPr sz="1100">
+                <a:solidFill>
+                  <a:srgbClr val="3C0A0A"/>
+                </a:solidFill>
+              </a:rPr>
+              <a:t>Ward (1963), JASA</a:t>
+            </a:r>
+          </a:p>
+        </p:txBody>
+      </p:sp>
     </p:spTree>
   </p:cSld>
   <p:clrMapOvr>
@@ -3391,9 +6106,87 @@
         <p:nvPr/>
       </p:nvGrpSpPr>
       <p:grpSpPr/>
+      <p:sp>
+        <p:nvSpPr>
+          <p:cNvPr id="2" name="Rectangle 1"/>
+          <p:cNvSpPr/>
+          <p:nvPr/>
+        </p:nvSpPr>
+        <p:spPr>
+          <a:xfrm>
+            <a:off x="0" y="0"/>
+            <a:ext cx="12188952" cy="685800"/>
+          </a:xfrm>
+          <a:prstGeom prst="rect">
+            <a:avLst/>
+          </a:prstGeom>
+          <a:solidFill>
+            <a:srgbClr val="4527A0"/>
+          </a:solidFill>
+          <a:ln>
+            <a:solidFill>
+              <a:srgbClr val="4527A0"/>
+            </a:solidFill>
+          </a:ln>
+        </p:spPr>
+        <p:style>
+          <a:lnRef idx="1">
+            <a:schemeClr val="accent1"/>
+          </a:lnRef>
+          <a:fillRef idx="3">
+            <a:schemeClr val="accent1"/>
+          </a:fillRef>
+          <a:effectRef idx="2">
+            <a:schemeClr val="accent1"/>
+          </a:effectRef>
+          <a:fontRef idx="minor">
+            <a:schemeClr val="lt1"/>
+          </a:fontRef>
+        </p:style>
+        <p:txBody>
+          <a:bodyPr rtlCol="0" anchor="ctr"/>
+          <a:lstStyle/>
+          <a:p>
+            <a:pPr algn="ctr"/>
+          </a:p>
+        </p:txBody>
+      </p:sp>
+      <p:sp>
+        <p:nvSpPr>
+          <p:cNvPr id="3" name="TextBox 2"/>
+          <p:cNvSpPr txBox="1"/>
+          <p:nvPr/>
+        </p:nvSpPr>
+        <p:spPr>
+          <a:xfrm>
+            <a:off x="182880" y="0"/>
+            <a:ext cx="8229600" cy="685800"/>
+          </a:xfrm>
+          <a:prstGeom prst="rect">
+            <a:avLst/>
+          </a:prstGeom>
+          <a:noFill/>
+        </p:spPr>
+        <p:txBody>
+          <a:bodyPr wrap="square">
+            <a:spAutoFit/>
+          </a:bodyPr>
+          <a:lstStyle/>
+          <a:p>
+            <a:r>
+              <a:rPr sz="2000" b="1">
+                <a:solidFill>
+                  <a:srgbClr val="FFFFFF"/>
+                </a:solidFill>
+              </a:rPr>
+              <a:t>07  |  HDBSCAN  (Hierarchical Density-Based Clustering)</a:t>
+            </a:r>
+          </a:p>
+        </p:txBody>
+      </p:sp>
       <p:pic>
         <p:nvPicPr>
-          <p:cNvPr id="2" name="Picture 1" descr="exec_slide_07_hdbscan.png"/>
+          <p:cNvPr id="4" name="Picture 3" descr="06_hdbscan.png"/>
           <p:cNvPicPr>
             <a:picLocks noChangeAspect="1"/>
           </p:cNvPicPr>
@@ -3407,14 +6200,349 @@
         </p:blipFill>
         <p:spPr>
           <a:xfrm>
-            <a:off x="0" y="0"/>
-            <a:ext cx="12188952" cy="6858000"/>
+            <a:off x="182880" y="777240"/>
+            <a:ext cx="7863840" cy="5852160"/>
           </a:xfrm>
           <a:prstGeom prst="rect">
             <a:avLst/>
           </a:prstGeom>
         </p:spPr>
       </p:pic>
+      <p:sp>
+        <p:nvSpPr>
+          <p:cNvPr id="5" name="Rectangle 4"/>
+          <p:cNvSpPr/>
+          <p:nvPr/>
+        </p:nvSpPr>
+        <p:spPr>
+          <a:xfrm>
+            <a:off x="8275320" y="777240"/>
+            <a:ext cx="3730752" cy="5852160"/>
+          </a:xfrm>
+          <a:prstGeom prst="rect">
+            <a:avLst/>
+          </a:prstGeom>
+          <a:solidFill>
+            <a:srgbClr val="EDE7F6"/>
+          </a:solidFill>
+          <a:ln w="12700">
+            <a:solidFill>
+              <a:srgbClr val="B39DDB"/>
+            </a:solidFill>
+          </a:ln>
+        </p:spPr>
+        <p:style>
+          <a:lnRef idx="1">
+            <a:schemeClr val="accent1"/>
+          </a:lnRef>
+          <a:fillRef idx="3">
+            <a:schemeClr val="accent1"/>
+          </a:fillRef>
+          <a:effectRef idx="2">
+            <a:schemeClr val="accent1"/>
+          </a:effectRef>
+          <a:fontRef idx="minor">
+            <a:schemeClr val="lt1"/>
+          </a:fontRef>
+        </p:style>
+        <p:txBody>
+          <a:bodyPr rtlCol="0" anchor="ctr"/>
+          <a:lstStyle/>
+          <a:p>
+            <a:pPr algn="ctr"/>
+          </a:p>
+        </p:txBody>
+      </p:sp>
+      <p:sp>
+        <p:nvSpPr>
+          <p:cNvPr id="6" name="TextBox 5"/>
+          <p:cNvSpPr txBox="1"/>
+          <p:nvPr/>
+        </p:nvSpPr>
+        <p:spPr>
+          <a:xfrm>
+            <a:off x="8366760" y="822960"/>
+            <a:ext cx="3566160" cy="5669280"/>
+          </a:xfrm>
+          <a:prstGeom prst="rect">
+            <a:avLst/>
+          </a:prstGeom>
+          <a:noFill/>
+        </p:spPr>
+        <p:txBody>
+          <a:bodyPr wrap="square">
+            <a:spAutoFit/>
+          </a:bodyPr>
+          <a:lstStyle/>
+          <a:p>
+            <a:r>
+              <a:rPr sz="1100">
+                <a:solidFill>
+                  <a:srgbClr val="190A3C"/>
+                </a:solidFill>
+              </a:rPr>
+              <a:t>Algorithm Summary</a:t>
+            </a:r>
+          </a:p>
+          <a:p/>
+          <a:p>
+            <a:r>
+              <a:rPr sz="1100">
+                <a:solidFill>
+                  <a:srgbClr val="190A3C"/>
+                </a:solidFill>
+              </a:rPr>
+              <a:t>Category: Density-Based</a:t>
+            </a:r>
+          </a:p>
+          <a:p/>
+          <a:p>
+            <a:r>
+              <a:rPr sz="1100">
+                <a:solidFill>
+                  <a:srgbClr val="190A3C"/>
+                </a:solidFill>
+              </a:rPr>
+              <a:t>Core Idea</a:t>
+            </a:r>
+          </a:p>
+          <a:p>
+            <a:r>
+              <a:rPr sz="1100">
+                <a:solidFill>
+                  <a:srgbClr val="190A3C"/>
+                </a:solidFill>
+              </a:rPr>
+              <a:t>밀도 계층 구조에서 안정적인 클러스터를 추출. 저밀도 영역 포인트 = 노이즈(−1).</a:t>
+            </a:r>
+          </a:p>
+          <a:p/>
+          <a:p>
+            <a:r>
+              <a:rPr sz="1100">
+                <a:solidFill>
+                  <a:srgbClr val="190A3C"/>
+                </a:solidFill>
+              </a:rPr>
+              <a:t>Algorithm</a:t>
+            </a:r>
+          </a:p>
+          <a:p>
+            <a:r>
+              <a:rPr sz="1100">
+                <a:solidFill>
+                  <a:srgbClr val="190A3C"/>
+                </a:solidFill>
+              </a:rPr>
+              <a:t>① Core distance 계산 (k-NN 기반)</a:t>
+            </a:r>
+          </a:p>
+          <a:p>
+            <a:r>
+              <a:rPr sz="1100">
+                <a:solidFill>
+                  <a:srgbClr val="190A3C"/>
+                </a:solidFill>
+              </a:rPr>
+              <a:t>② Mutual reachability graph 구성</a:t>
+            </a:r>
+          </a:p>
+          <a:p>
+            <a:r>
+              <a:rPr sz="1100">
+                <a:solidFill>
+                  <a:srgbClr val="190A3C"/>
+                </a:solidFill>
+              </a:rPr>
+              <a:t>③ Minimum spanning tree 생성</a:t>
+            </a:r>
+          </a:p>
+          <a:p>
+            <a:r>
+              <a:rPr sz="1100">
+                <a:solidFill>
+                  <a:srgbClr val="190A3C"/>
+                </a:solidFill>
+              </a:rPr>
+              <a:t>④ 클러스터 계층 condensation</a:t>
+            </a:r>
+          </a:p>
+          <a:p>
+            <a:r>
+              <a:rPr sz="1100">
+                <a:solidFill>
+                  <a:srgbClr val="190A3C"/>
+                </a:solidFill>
+              </a:rPr>
+              <a:t>⑤ Cluster stability 최대화로 추출</a:t>
+            </a:r>
+          </a:p>
+          <a:p>
+            <a:r>
+              <a:rPr sz="1100">
+                <a:solidFill>
+                  <a:srgbClr val="190A3C"/>
+                </a:solidFill>
+              </a:rPr>
+              <a:t>   stability = Σ(λ_death − λ_birth)</a:t>
+            </a:r>
+          </a:p>
+          <a:p/>
+          <a:p>
+            <a:r>
+              <a:rPr sz="1100">
+                <a:solidFill>
+                  <a:srgbClr val="190A3C"/>
+                </a:solidFill>
+              </a:rPr>
+              <a:t>Key Parameters</a:t>
+            </a:r>
+          </a:p>
+          <a:p>
+            <a:r>
+              <a:rPr sz="1100">
+                <a:solidFill>
+                  <a:srgbClr val="190A3C"/>
+                </a:solidFill>
+              </a:rPr>
+              <a:t>• min_cluster_size: 최소 클러스터 크기</a:t>
+            </a:r>
+          </a:p>
+          <a:p>
+            <a:r>
+              <a:rPr sz="1100">
+                <a:solidFill>
+                  <a:srgbClr val="190A3C"/>
+                </a:solidFill>
+              </a:rPr>
+              <a:t>• min_samples: core point 기준</a:t>
+            </a:r>
+          </a:p>
+          <a:p/>
+          <a:p>
+            <a:r>
+              <a:rPr sz="1100">
+                <a:solidFill>
+                  <a:srgbClr val="190A3C"/>
+                </a:solidFill>
+              </a:rPr>
+              <a:t>Properties</a:t>
+            </a:r>
+          </a:p>
+          <a:p>
+            <a:r>
+              <a:rPr sz="1100">
+                <a:solidFill>
+                  <a:srgbClr val="190A3C"/>
+                </a:solidFill>
+              </a:rPr>
+              <a:t>✓ k 사전 지정 불필요</a:t>
+            </a:r>
+          </a:p>
+          <a:p>
+            <a:r>
+              <a:rPr sz="1100">
+                <a:solidFill>
+                  <a:srgbClr val="190A3C"/>
+                </a:solidFill>
+              </a:rPr>
+              <a:t>✓ 가변 밀도 클러스터 처리</a:t>
+            </a:r>
+          </a:p>
+          <a:p>
+            <a:r>
+              <a:rPr sz="1100">
+                <a:solidFill>
+                  <a:srgbClr val="190A3C"/>
+                </a:solidFill>
+              </a:rPr>
+              <a:t>✓ 임의 형상 클러스터 탐지</a:t>
+            </a:r>
+          </a:p>
+          <a:p>
+            <a:r>
+              <a:rPr sz="1100">
+                <a:solidFill>
+                  <a:srgbClr val="190A3C"/>
+                </a:solidFill>
+              </a:rPr>
+              <a:t>✓ 노이즈/이상치 자동 분리</a:t>
+            </a:r>
+          </a:p>
+          <a:p>
+            <a:r>
+              <a:rPr sz="1100">
+                <a:solidFill>
+                  <a:srgbClr val="190A3C"/>
+                </a:solidFill>
+              </a:rPr>
+              <a:t>✓ Soft membership 확률 제공</a:t>
+            </a:r>
+          </a:p>
+          <a:p/>
+          <a:p>
+            <a:r>
+              <a:rPr sz="1100">
+                <a:solidFill>
+                  <a:srgbClr val="190A3C"/>
+                </a:solidFill>
+              </a:rPr>
+              <a:t>vs DBSCAN</a:t>
+            </a:r>
+          </a:p>
+          <a:p>
+            <a:r>
+              <a:rPr sz="1100">
+                <a:solidFill>
+                  <a:srgbClr val="190A3C"/>
+                </a:solidFill>
+              </a:rPr>
+              <a:t>HDBSCAN은 ε 파라미터 불필요</a:t>
+            </a:r>
+          </a:p>
+          <a:p>
+            <a:r>
+              <a:rPr sz="1100">
+                <a:solidFill>
+                  <a:srgbClr val="190A3C"/>
+                </a:solidFill>
+              </a:rPr>
+              <a:t>→ 스케일 불변(scale-invariant)</a:t>
+            </a:r>
+          </a:p>
+          <a:p/>
+          <a:p>
+            <a:r>
+              <a:rPr sz="1100">
+                <a:solidFill>
+                  <a:srgbClr val="190A3C"/>
+                </a:solidFill>
+              </a:rPr>
+              <a:t>Reference</a:t>
+            </a:r>
+          </a:p>
+          <a:p>
+            <a:r>
+              <a:rPr sz="1100">
+                <a:solidFill>
+                  <a:srgbClr val="190A3C"/>
+                </a:solidFill>
+              </a:rPr>
+              <a:t>Campello et al. (2013), PAKDD</a:t>
+            </a:r>
+          </a:p>
+          <a:p>
+            <a:r>
+              <a:rPr sz="1100">
+                <a:solidFill>
+                  <a:srgbClr val="190A3C"/>
+                </a:solidFill>
+              </a:rPr>
+              <a:t>McInnes et al. (2017), JOSS</a:t>
+            </a:r>
+          </a:p>
+        </p:txBody>
+      </p:sp>
     </p:spTree>
   </p:cSld>
   <p:clrMapOvr>
@@ -3433,9 +6561,87 @@
         <p:nvPr/>
       </p:nvGrpSpPr>
       <p:grpSpPr/>
+      <p:sp>
+        <p:nvSpPr>
+          <p:cNvPr id="2" name="Rectangle 1"/>
+          <p:cNvSpPr/>
+          <p:nvPr/>
+        </p:nvSpPr>
+        <p:spPr>
+          <a:xfrm>
+            <a:off x="0" y="0"/>
+            <a:ext cx="12188952" cy="685800"/>
+          </a:xfrm>
+          <a:prstGeom prst="rect">
+            <a:avLst/>
+          </a:prstGeom>
+          <a:solidFill>
+            <a:srgbClr val="1B5E20"/>
+          </a:solidFill>
+          <a:ln>
+            <a:solidFill>
+              <a:srgbClr val="1B5E20"/>
+            </a:solidFill>
+          </a:ln>
+        </p:spPr>
+        <p:style>
+          <a:lnRef idx="1">
+            <a:schemeClr val="accent1"/>
+          </a:lnRef>
+          <a:fillRef idx="3">
+            <a:schemeClr val="accent1"/>
+          </a:fillRef>
+          <a:effectRef idx="2">
+            <a:schemeClr val="accent1"/>
+          </a:effectRef>
+          <a:fontRef idx="minor">
+            <a:schemeClr val="lt1"/>
+          </a:fontRef>
+        </p:style>
+        <p:txBody>
+          <a:bodyPr rtlCol="0" anchor="ctr"/>
+          <a:lstStyle/>
+          <a:p>
+            <a:pPr algn="ctr"/>
+          </a:p>
+        </p:txBody>
+      </p:sp>
+      <p:sp>
+        <p:nvSpPr>
+          <p:cNvPr id="3" name="TextBox 2"/>
+          <p:cNvSpPr txBox="1"/>
+          <p:nvPr/>
+        </p:nvSpPr>
+        <p:spPr>
+          <a:xfrm>
+            <a:off x="182880" y="0"/>
+            <a:ext cx="8229600" cy="685800"/>
+          </a:xfrm>
+          <a:prstGeom prst="rect">
+            <a:avLst/>
+          </a:prstGeom>
+          <a:noFill/>
+        </p:spPr>
+        <p:txBody>
+          <a:bodyPr wrap="square">
+            <a:spAutoFit/>
+          </a:bodyPr>
+          <a:lstStyle/>
+          <a:p>
+            <a:r>
+              <a:rPr sz="2400" b="1">
+                <a:solidFill>
+                  <a:srgbClr val="FFFFFF"/>
+                </a:solidFill>
+              </a:rPr>
+              <a:t>08  |  Spectral Clustering</a:t>
+            </a:r>
+          </a:p>
+        </p:txBody>
+      </p:sp>
       <p:pic>
         <p:nvPicPr>
-          <p:cNvPr id="2" name="Picture 1" descr="exec_slide_08_spectral.png"/>
+          <p:cNvPr id="4" name="Picture 3" descr="07_spectral_new.png"/>
           <p:cNvPicPr>
             <a:picLocks noChangeAspect="1"/>
           </p:cNvPicPr>
@@ -3449,14 +6655,338 @@
         </p:blipFill>
         <p:spPr>
           <a:xfrm>
-            <a:off x="0" y="0"/>
-            <a:ext cx="12188952" cy="6858000"/>
+            <a:off x="182880" y="777240"/>
+            <a:ext cx="7863840" cy="5852160"/>
           </a:xfrm>
           <a:prstGeom prst="rect">
             <a:avLst/>
           </a:prstGeom>
         </p:spPr>
       </p:pic>
+      <p:sp>
+        <p:nvSpPr>
+          <p:cNvPr id="5" name="Rectangle 4"/>
+          <p:cNvSpPr/>
+          <p:nvPr/>
+        </p:nvSpPr>
+        <p:spPr>
+          <a:xfrm>
+            <a:off x="8275320" y="777240"/>
+            <a:ext cx="3730752" cy="5852160"/>
+          </a:xfrm>
+          <a:prstGeom prst="rect">
+            <a:avLst/>
+          </a:prstGeom>
+          <a:solidFill>
+            <a:srgbClr val="E8F5E9"/>
+          </a:solidFill>
+          <a:ln w="12700">
+            <a:solidFill>
+              <a:srgbClr val="A5D6A7"/>
+            </a:solidFill>
+          </a:ln>
+        </p:spPr>
+        <p:style>
+          <a:lnRef idx="1">
+            <a:schemeClr val="accent1"/>
+          </a:lnRef>
+          <a:fillRef idx="3">
+            <a:schemeClr val="accent1"/>
+          </a:fillRef>
+          <a:effectRef idx="2">
+            <a:schemeClr val="accent1"/>
+          </a:effectRef>
+          <a:fontRef idx="minor">
+            <a:schemeClr val="lt1"/>
+          </a:fontRef>
+        </p:style>
+        <p:txBody>
+          <a:bodyPr rtlCol="0" anchor="ctr"/>
+          <a:lstStyle/>
+          <a:p>
+            <a:pPr algn="ctr"/>
+          </a:p>
+        </p:txBody>
+      </p:sp>
+      <p:sp>
+        <p:nvSpPr>
+          <p:cNvPr id="6" name="TextBox 5"/>
+          <p:cNvSpPr txBox="1"/>
+          <p:nvPr/>
+        </p:nvSpPr>
+        <p:spPr>
+          <a:xfrm>
+            <a:off x="8366760" y="822960"/>
+            <a:ext cx="3566160" cy="5669280"/>
+          </a:xfrm>
+          <a:prstGeom prst="rect">
+            <a:avLst/>
+          </a:prstGeom>
+          <a:noFill/>
+        </p:spPr>
+        <p:txBody>
+          <a:bodyPr wrap="square">
+            <a:spAutoFit/>
+          </a:bodyPr>
+          <a:lstStyle/>
+          <a:p>
+            <a:r>
+              <a:rPr sz="1100">
+                <a:solidFill>
+                  <a:srgbClr val="0A280A"/>
+                </a:solidFill>
+              </a:rPr>
+              <a:t>Algorithm Summary</a:t>
+            </a:r>
+          </a:p>
+          <a:p/>
+          <a:p>
+            <a:r>
+              <a:rPr sz="1100">
+                <a:solidFill>
+                  <a:srgbClr val="0A280A"/>
+                </a:solidFill>
+              </a:rPr>
+              <a:t>Category: Graph-Based</a:t>
+            </a:r>
+          </a:p>
+          <a:p/>
+          <a:p>
+            <a:r>
+              <a:rPr sz="1100">
+                <a:solidFill>
+                  <a:srgbClr val="0A280A"/>
+                </a:solidFill>
+              </a:rPr>
+              <a:t>Core Idea</a:t>
+            </a:r>
+          </a:p>
+          <a:p>
+            <a:r>
+              <a:rPr sz="1100">
+                <a:solidFill>
+                  <a:srgbClr val="0A280A"/>
+                </a:solidFill>
+              </a:rPr>
+              <a:t>그래프 Laplacian의 고유벡터로 저차원 임베딩 생성 후 K-Means 적용. 비볼록 클러스터 탐지.</a:t>
+            </a:r>
+          </a:p>
+          <a:p/>
+          <a:p>
+            <a:r>
+              <a:rPr sz="1100">
+                <a:solidFill>
+                  <a:srgbClr val="0A280A"/>
+                </a:solidFill>
+              </a:rPr>
+              <a:t>Algorithm</a:t>
+            </a:r>
+          </a:p>
+          <a:p>
+            <a:r>
+              <a:rPr sz="1100">
+                <a:solidFill>
+                  <a:srgbClr val="0A280A"/>
+                </a:solidFill>
+              </a:rPr>
+              <a:t>① Affinity matrix W 구성</a:t>
+            </a:r>
+          </a:p>
+          <a:p>
+            <a:r>
+              <a:rPr sz="1100">
+                <a:solidFill>
+                  <a:srgbClr val="0A280A"/>
+                </a:solidFill>
+              </a:rPr>
+              <a:t>   Wᵢⱼ = exp(−‖xᵢ−xⱼ‖²/2σ²)</a:t>
+            </a:r>
+          </a:p>
+          <a:p>
+            <a:r>
+              <a:rPr sz="1100">
+                <a:solidFill>
+                  <a:srgbClr val="0A280A"/>
+                </a:solidFill>
+              </a:rPr>
+              <a:t>② Degree matrix D 계산</a:t>
+            </a:r>
+          </a:p>
+          <a:p>
+            <a:r>
+              <a:rPr sz="1100">
+                <a:solidFill>
+                  <a:srgbClr val="0A280A"/>
+                </a:solidFill>
+              </a:rPr>
+              <a:t>   Dᵢᵢ = Σⱼ Wᵢⱼ</a:t>
+            </a:r>
+          </a:p>
+          <a:p>
+            <a:r>
+              <a:rPr sz="1100">
+                <a:solidFill>
+                  <a:srgbClr val="0A280A"/>
+                </a:solidFill>
+              </a:rPr>
+              <a:t>③ Normalized Laplacian</a:t>
+            </a:r>
+          </a:p>
+          <a:p>
+            <a:r>
+              <a:rPr sz="1100">
+                <a:solidFill>
+                  <a:srgbClr val="0A280A"/>
+                </a:solidFill>
+              </a:rPr>
+              <a:t>   L = D⁻½(D−W)D⁻½</a:t>
+            </a:r>
+          </a:p>
+          <a:p>
+            <a:r>
+              <a:rPr sz="1100">
+                <a:solidFill>
+                  <a:srgbClr val="0A280A"/>
+                </a:solidFill>
+              </a:rPr>
+              <a:t>④ Top-k 고유벡터 추출 → U ∈ ℝⁿˣᵏ</a:t>
+            </a:r>
+          </a:p>
+          <a:p>
+            <a:r>
+              <a:rPr sz="1100">
+                <a:solidFill>
+                  <a:srgbClr val="0A280A"/>
+                </a:solidFill>
+              </a:rPr>
+              <a:t>⑤ U의 행 정규화 후 K-Means</a:t>
+            </a:r>
+          </a:p>
+          <a:p/>
+          <a:p>
+            <a:r>
+              <a:rPr sz="1100">
+                <a:solidFill>
+                  <a:srgbClr val="0A280A"/>
+                </a:solidFill>
+              </a:rPr>
+              <a:t>Key Parameters</a:t>
+            </a:r>
+          </a:p>
+          <a:p>
+            <a:r>
+              <a:rPr sz="1100">
+                <a:solidFill>
+                  <a:srgbClr val="0A280A"/>
+                </a:solidFill>
+              </a:rPr>
+              <a:t>• σ (bandwidth): 유사도 스케일</a:t>
+            </a:r>
+          </a:p>
+          <a:p>
+            <a:r>
+              <a:rPr sz="1100">
+                <a:solidFill>
+                  <a:srgbClr val="0A280A"/>
+                </a:solidFill>
+              </a:rPr>
+              <a:t>• k: 클러스터 수 = 고유벡터 수</a:t>
+            </a:r>
+          </a:p>
+          <a:p/>
+          <a:p>
+            <a:r>
+              <a:rPr sz="1100">
+                <a:solidFill>
+                  <a:srgbClr val="0A280A"/>
+                </a:solidFill>
+              </a:rPr>
+              <a:t>Properties</a:t>
+            </a:r>
+          </a:p>
+          <a:p>
+            <a:r>
+              <a:rPr sz="1100">
+                <a:solidFill>
+                  <a:srgbClr val="0A280A"/>
+                </a:solidFill>
+              </a:rPr>
+              <a:t>✓ 고리형/비볼록 클러스터 탐지</a:t>
+            </a:r>
+          </a:p>
+          <a:p>
+            <a:r>
+              <a:rPr sz="1100">
+                <a:solidFill>
+                  <a:srgbClr val="0A280A"/>
+                </a:solidFill>
+              </a:rPr>
+              <a:t>✓ 그래프/유사도 데이터에 적합</a:t>
+            </a:r>
+          </a:p>
+          <a:p>
+            <a:r>
+              <a:rPr sz="1100">
+                <a:solidFill>
+                  <a:srgbClr val="0A280A"/>
+                </a:solidFill>
+              </a:rPr>
+              <a:t>✓ 거리 공간 불필요</a:t>
+            </a:r>
+          </a:p>
+          <a:p>
+            <a:r>
+              <a:rPr sz="1100">
+                <a:solidFill>
+                  <a:srgbClr val="0A280A"/>
+                </a:solidFill>
+              </a:rPr>
+              <a:t>△ O(n³) 고유분해 → 서브샘플 필요</a:t>
+            </a:r>
+          </a:p>
+          <a:p>
+            <a:r>
+              <a:rPr sz="1100">
+                <a:solidFill>
+                  <a:srgbClr val="0A280A"/>
+                </a:solidFill>
+              </a:rPr>
+              <a:t>△ σ 파라미터 민감</a:t>
+            </a:r>
+          </a:p>
+          <a:p/>
+          <a:p>
+            <a:r>
+              <a:rPr sz="1100">
+                <a:solidFill>
+                  <a:srgbClr val="0A280A"/>
+                </a:solidFill>
+              </a:rPr>
+              <a:t>Reference</a:t>
+            </a:r>
+          </a:p>
+          <a:p>
+            <a:r>
+              <a:rPr sz="1100">
+                <a:solidFill>
+                  <a:srgbClr val="0A280A"/>
+                </a:solidFill>
+              </a:rPr>
+              <a:t>Ng et al. (2001), NIPS</a:t>
+            </a:r>
+          </a:p>
+          <a:p>
+            <a:r>
+              <a:rPr sz="1100">
+                <a:solidFill>
+                  <a:srgbClr val="0A280A"/>
+                </a:solidFill>
+              </a:rPr>
+              <a:t>Von Luxburg (2007), Stat &amp; Comput.</a:t>
+            </a:r>
+          </a:p>
+        </p:txBody>
+      </p:sp>
     </p:spTree>
   </p:cSld>
   <p:clrMapOvr>
@@ -3475,9 +7005,87 @@
         <p:nvPr/>
       </p:nvGrpSpPr>
       <p:grpSpPr/>
+      <p:sp>
+        <p:nvSpPr>
+          <p:cNvPr id="2" name="Rectangle 1"/>
+          <p:cNvSpPr/>
+          <p:nvPr/>
+        </p:nvSpPr>
+        <p:spPr>
+          <a:xfrm>
+            <a:off x="0" y="0"/>
+            <a:ext cx="12188952" cy="685800"/>
+          </a:xfrm>
+          <a:prstGeom prst="rect">
+            <a:avLst/>
+          </a:prstGeom>
+          <a:solidFill>
+            <a:srgbClr val="BF360C"/>
+          </a:solidFill>
+          <a:ln>
+            <a:solidFill>
+              <a:srgbClr val="BF360C"/>
+            </a:solidFill>
+          </a:ln>
+        </p:spPr>
+        <p:style>
+          <a:lnRef idx="1">
+            <a:schemeClr val="accent1"/>
+          </a:lnRef>
+          <a:fillRef idx="3">
+            <a:schemeClr val="accent1"/>
+          </a:fillRef>
+          <a:effectRef idx="2">
+            <a:schemeClr val="accent1"/>
+          </a:effectRef>
+          <a:fontRef idx="minor">
+            <a:schemeClr val="lt1"/>
+          </a:fontRef>
+        </p:style>
+        <p:txBody>
+          <a:bodyPr rtlCol="0" anchor="ctr"/>
+          <a:lstStyle/>
+          <a:p>
+            <a:pPr algn="ctr"/>
+          </a:p>
+        </p:txBody>
+      </p:sp>
+      <p:sp>
+        <p:nvSpPr>
+          <p:cNvPr id="3" name="TextBox 2"/>
+          <p:cNvSpPr txBox="1"/>
+          <p:nvPr/>
+        </p:nvSpPr>
+        <p:spPr>
+          <a:xfrm>
+            <a:off x="182880" y="0"/>
+            <a:ext cx="8229600" cy="685800"/>
+          </a:xfrm>
+          <a:prstGeom prst="rect">
+            <a:avLst/>
+          </a:prstGeom>
+          <a:noFill/>
+        </p:spPr>
+        <p:txBody>
+          <a:bodyPr wrap="square">
+            <a:spAutoFit/>
+          </a:bodyPr>
+          <a:lstStyle/>
+          <a:p>
+            <a:r>
+              <a:rPr sz="2000" b="1">
+                <a:solidFill>
+                  <a:srgbClr val="FFFFFF"/>
+                </a:solidFill>
+              </a:rPr>
+              <a:t>09  |  Isolation Forest + K-Means  (Two-Stage Pipeline)</a:t>
+            </a:r>
+          </a:p>
+        </p:txBody>
+      </p:sp>
       <p:pic>
         <p:nvPicPr>
-          <p:cNvPr id="2" name="Picture 1" descr="exec_slide_09_isolation_forest_kmeans.png"/>
+          <p:cNvPr id="4" name="Picture 3" descr="08_isolation_forest.png"/>
           <p:cNvPicPr>
             <a:picLocks noChangeAspect="1"/>
           </p:cNvPicPr>
@@ -3491,14 +7099,329 @@
         </p:blipFill>
         <p:spPr>
           <a:xfrm>
-            <a:off x="0" y="0"/>
-            <a:ext cx="12188952" cy="6858000"/>
+            <a:off x="182880" y="777240"/>
+            <a:ext cx="7863840" cy="5852160"/>
           </a:xfrm>
           <a:prstGeom prst="rect">
             <a:avLst/>
           </a:prstGeom>
         </p:spPr>
       </p:pic>
+      <p:sp>
+        <p:nvSpPr>
+          <p:cNvPr id="5" name="Rectangle 4"/>
+          <p:cNvSpPr/>
+          <p:nvPr/>
+        </p:nvSpPr>
+        <p:spPr>
+          <a:xfrm>
+            <a:off x="8275320" y="777240"/>
+            <a:ext cx="3730752" cy="5852160"/>
+          </a:xfrm>
+          <a:prstGeom prst="rect">
+            <a:avLst/>
+          </a:prstGeom>
+          <a:solidFill>
+            <a:srgbClr val="FBE9E7"/>
+          </a:solidFill>
+          <a:ln w="12700">
+            <a:solidFill>
+              <a:srgbClr val="EF9A9A"/>
+            </a:solidFill>
+          </a:ln>
+        </p:spPr>
+        <p:style>
+          <a:lnRef idx="1">
+            <a:schemeClr val="accent1"/>
+          </a:lnRef>
+          <a:fillRef idx="3">
+            <a:schemeClr val="accent1"/>
+          </a:fillRef>
+          <a:effectRef idx="2">
+            <a:schemeClr val="accent1"/>
+          </a:effectRef>
+          <a:fontRef idx="minor">
+            <a:schemeClr val="lt1"/>
+          </a:fontRef>
+        </p:style>
+        <p:txBody>
+          <a:bodyPr rtlCol="0" anchor="ctr"/>
+          <a:lstStyle/>
+          <a:p>
+            <a:pPr algn="ctr"/>
+          </a:p>
+        </p:txBody>
+      </p:sp>
+      <p:sp>
+        <p:nvSpPr>
+          <p:cNvPr id="6" name="TextBox 5"/>
+          <p:cNvSpPr txBox="1"/>
+          <p:nvPr/>
+        </p:nvSpPr>
+        <p:spPr>
+          <a:xfrm>
+            <a:off x="8366760" y="822960"/>
+            <a:ext cx="3566160" cy="5669280"/>
+          </a:xfrm>
+          <a:prstGeom prst="rect">
+            <a:avLst/>
+          </a:prstGeom>
+          <a:noFill/>
+        </p:spPr>
+        <p:txBody>
+          <a:bodyPr wrap="square">
+            <a:spAutoFit/>
+          </a:bodyPr>
+          <a:lstStyle/>
+          <a:p>
+            <a:r>
+              <a:rPr sz="1100">
+                <a:solidFill>
+                  <a:srgbClr val="3C0F05"/>
+                </a:solidFill>
+              </a:rPr>
+              <a:t>Algorithm Summary</a:t>
+            </a:r>
+          </a:p>
+          <a:p/>
+          <a:p>
+            <a:r>
+              <a:rPr sz="1100">
+                <a:solidFill>
+                  <a:srgbClr val="3C0F05"/>
+                </a:solidFill>
+              </a:rPr>
+              <a:t>Category: Hybrid (Anomaly + Partition)</a:t>
+            </a:r>
+          </a:p>
+          <a:p/>
+          <a:p>
+            <a:r>
+              <a:rPr sz="1100">
+                <a:solidFill>
+                  <a:srgbClr val="3C0F05"/>
+                </a:solidFill>
+              </a:rPr>
+              <a:t>Core Idea</a:t>
+            </a:r>
+          </a:p>
+          <a:p>
+            <a:r>
+              <a:rPr sz="1100">
+                <a:solidFill>
+                  <a:srgbClr val="3C0F05"/>
+                </a:solidFill>
+              </a:rPr>
+              <a:t>2단계 파이프라인: 먼저 이상치 제거 후 정제된 데이터에 K-Means 적용. 이상치 = label −1.</a:t>
+            </a:r>
+          </a:p>
+          <a:p/>
+          <a:p>
+            <a:r>
+              <a:rPr sz="1100">
+                <a:solidFill>
+                  <a:srgbClr val="3C0F05"/>
+                </a:solidFill>
+              </a:rPr>
+              <a:t>Stage 1: Isolation Forest</a:t>
+            </a:r>
+          </a:p>
+          <a:p>
+            <a:r>
+              <a:rPr sz="1100">
+                <a:solidFill>
+                  <a:srgbClr val="3C0F05"/>
+                </a:solidFill>
+              </a:rPr>
+              <a:t>• Random iTree 앙상블 구성</a:t>
+            </a:r>
+          </a:p>
+          <a:p>
+            <a:r>
+              <a:rPr sz="1100">
+                <a:solidFill>
+                  <a:srgbClr val="3C0F05"/>
+                </a:solidFill>
+              </a:rPr>
+              <a:t>• 이상치 점수: 짧은 경로 = 이상</a:t>
+            </a:r>
+          </a:p>
+          <a:p>
+            <a:r>
+              <a:rPr sz="1100">
+                <a:solidFill>
+                  <a:srgbClr val="3C0F05"/>
+                </a:solidFill>
+              </a:rPr>
+              <a:t>s(x,n) = 2^{−E[h(x)]/c(n)}</a:t>
+            </a:r>
+          </a:p>
+          <a:p>
+            <a:r>
+              <a:rPr sz="1100">
+                <a:solidFill>
+                  <a:srgbClr val="3C0F05"/>
+                </a:solidFill>
+              </a:rPr>
+              <a:t>• contamination으로 비율 제어</a:t>
+            </a:r>
+          </a:p>
+          <a:p/>
+          <a:p>
+            <a:r>
+              <a:rPr sz="1100">
+                <a:solidFill>
+                  <a:srgbClr val="3C0F05"/>
+                </a:solidFill>
+              </a:rPr>
+              <a:t>Stage 2: K-Means (Inliers only)</a:t>
+            </a:r>
+          </a:p>
+          <a:p>
+            <a:r>
+              <a:rPr sz="1100">
+                <a:solidFill>
+                  <a:srgbClr val="3C0F05"/>
+                </a:solidFill>
+              </a:rPr>
+              <a:t>• 이상치 필터링 후 K-Means</a:t>
+            </a:r>
+          </a:p>
+          <a:p>
+            <a:r>
+              <a:rPr sz="1100">
+                <a:solidFill>
+                  <a:srgbClr val="3C0F05"/>
+                </a:solidFill>
+              </a:rPr>
+              <a:t>• 정제 데이터로 centroid 학습</a:t>
+            </a:r>
+          </a:p>
+          <a:p>
+            <a:r>
+              <a:rPr sz="1100">
+                <a:solidFill>
+                  <a:srgbClr val="3C0F05"/>
+                </a:solidFill>
+              </a:rPr>
+              <a:t>• 필터된 이상치 → label −1 유지</a:t>
+            </a:r>
+          </a:p>
+          <a:p/>
+          <a:p>
+            <a:r>
+              <a:rPr sz="1100">
+                <a:solidFill>
+                  <a:srgbClr val="3C0F05"/>
+                </a:solidFill>
+              </a:rPr>
+              <a:t>Two-Stage Pipeline</a:t>
+            </a:r>
+          </a:p>
+          <a:p>
+            <a:r>
+              <a:rPr sz="1100">
+                <a:solidFill>
+                  <a:srgbClr val="3C0F05"/>
+                </a:solidFill>
+              </a:rPr>
+              <a:t>Raw Data → Isolation Forest</a:t>
+            </a:r>
+          </a:p>
+          <a:p>
+            <a:r>
+              <a:rPr sz="1100">
+                <a:solidFill>
+                  <a:srgbClr val="3C0F05"/>
+                </a:solidFill>
+              </a:rPr>
+              <a:t>→ Outlier Filter → K-Means → Labels</a:t>
+            </a:r>
+          </a:p>
+          <a:p/>
+          <a:p>
+            <a:r>
+              <a:rPr sz="1100">
+                <a:solidFill>
+                  <a:srgbClr val="3C0F05"/>
+                </a:solidFill>
+              </a:rPr>
+              <a:t>Properties</a:t>
+            </a:r>
+          </a:p>
+          <a:p>
+            <a:r>
+              <a:rPr sz="1100">
+                <a:solidFill>
+                  <a:srgbClr val="3C0F05"/>
+                </a:solidFill>
+              </a:rPr>
+              <a:t>✓ 이상치가 centroid를 왜곡하지 않음</a:t>
+            </a:r>
+          </a:p>
+          <a:p>
+            <a:r>
+              <a:rPr sz="1100">
+                <a:solidFill>
+                  <a:srgbClr val="3C0F05"/>
+                </a:solidFill>
+              </a:rPr>
+              <a:t>✓ 이상치 점수 해석 가능</a:t>
+            </a:r>
+          </a:p>
+          <a:p>
+            <a:r>
+              <a:rPr sz="1100">
+                <a:solidFill>
+                  <a:srgbClr val="3C0F05"/>
+                </a:solidFill>
+              </a:rPr>
+              <a:t>✓ 불량 레이아웃 패턴 자동 분리</a:t>
+            </a:r>
+          </a:p>
+          <a:p>
+            <a:r>
+              <a:rPr sz="1100">
+                <a:solidFill>
+                  <a:srgbClr val="3C0F05"/>
+                </a:solidFill>
+              </a:rPr>
+              <a:t>✓ 반도체 결함 데이터에 특히 유효</a:t>
+            </a:r>
+          </a:p>
+          <a:p/>
+          <a:p>
+            <a:r>
+              <a:rPr sz="1100">
+                <a:solidFill>
+                  <a:srgbClr val="3C0F05"/>
+                </a:solidFill>
+              </a:rPr>
+              <a:t>Reference</a:t>
+            </a:r>
+          </a:p>
+          <a:p>
+            <a:r>
+              <a:rPr sz="1100">
+                <a:solidFill>
+                  <a:srgbClr val="3C0F05"/>
+                </a:solidFill>
+              </a:rPr>
+              <a:t>Liu et al. (2008), ICDM</a:t>
+            </a:r>
+          </a:p>
+          <a:p>
+            <a:r>
+              <a:rPr sz="1100">
+                <a:solidFill>
+                  <a:srgbClr val="3C0F05"/>
+                </a:solidFill>
+              </a:rPr>
+              <a:t>Isolation Forest (scikit-learn)</a:t>
+            </a:r>
+          </a:p>
+        </p:txBody>
+      </p:sp>
     </p:spTree>
   </p:cSld>
   <p:clrMapOvr>

</xml_diff>